<commit_message>
Revise granddaughter PPT: life stages, correct year-15 cash value
- Fix HK$286,059 to policy year 15 (age 24), not year 5
- Add why 寰御安心 for granddaughter savings as main theme
- Map returns to grad, work, marriage, children, home, business
- Expand to 13 slides with life-stage table from proposal PDF

Co-authored-by: hoyinlung25-commits <hoyinlung25-commits@users.noreply.github.com>
</commit_message>
<xml_diff>
--- a/client-base/presentations/Granddaughter_Savings_Plan_BOC.pptx
+++ b/client-base/presentations/Granddaughter_Savings_Plan_BOC.pptx
@@ -17,6 +17,7 @@
     <p:sldId id="265" r:id="rId16"/>
     <p:sldId id="266" r:id="rId17"/>
     <p:sldId id="267" r:id="rId18"/>
+    <p:sldId id="268" r:id="rId19"/>
   </p:sldIdLst>
   <p:sldSz cx="9144000" cy="6858000" type="screen4x3"/>
   <p:notesSz cx="6858000" cy="9144000"/>
@@ -3115,7 +3116,7 @@
         </p:nvSpPr>
         <p:spPr>
           <a:xfrm>
-            <a:off x="548640" y="2011680"/>
+            <a:off x="548640" y="1828800"/>
             <a:ext cx="8046720" cy="1097280"/>
           </a:xfrm>
           <a:prstGeom prst="rect">
@@ -3138,7 +3139,11 @@
               </a:defRPr>
             </a:pPr>
             <a:r>
-              <a:t>為孫女準備的一份長遠心意</a:t>
+              <a:t>爺爺為 9 歲孫女</a:t>
+            </a:r>
+            <a:br/>
+            <a:r>
+              <a:t>準備的長遠儲蓄心意</a:t>
             </a:r>
           </a:p>
         </p:txBody>
@@ -3151,8 +3156,8 @@
         </p:nvSpPr>
         <p:spPr>
           <a:xfrm>
-            <a:off x="731520" y="3200400"/>
-            <a:ext cx="7680960" cy="1371600"/>
+            <a:off x="731520" y="3017520"/>
+            <a:ext cx="7680960" cy="1463040"/>
           </a:xfrm>
           <a:prstGeom prst="rect">
             <a:avLst/>
@@ -3174,11 +3179,11 @@
               </a:defRPr>
             </a:pPr>
             <a:r>
-              <a:t>寰御安心環球終身保險計劃｜一次性預繳 HK$150,000</a:t>
+              <a:t>寰御安心環球終身保險計劃｜一次性預繳約 HK$150,000</a:t>
             </a:r>
             <a:br/>
             <a:r>
-              <a:t>建議書日期：2026年6月4日</a:t>
+              <a:t>按孫女人生階段，看保單如何為她累積資金</a:t>
             </a:r>
           </a:p>
         </p:txBody>
@@ -3319,7 +3324,7 @@
               </a:defRPr>
             </a:pPr>
             <a:r>
-              <a:t>預繳保費戶口（配合您的一次過供款）</a:t>
+              <a:t>長遠參考：孫女 65 歲</a:t>
             </a:r>
           </a:p>
         </p:txBody>
@@ -3332,8 +3337,8 @@
         </p:nvSpPr>
         <p:spPr>
           <a:xfrm>
-            <a:off x="685800" y="1828800"/>
-            <a:ext cx="7772400" cy="594360"/>
+            <a:off x="548640" y="1051560"/>
+            <a:ext cx="8046720" cy="502920"/>
           </a:xfrm>
           <a:prstGeom prst="rect">
             <a:avLst/>
@@ -3347,15 +3352,15 @@
           <a:lstStyle/>
           <a:p>
             <a:pPr algn="l">
-              <a:defRPr sz="1800" b="0">
-                <a:solidFill>
-                  <a:srgbClr val="4A5568"/>
+              <a:defRPr sz="1600" b="0">
+                <a:solidFill>
+                  <a:srgbClr val="718590"/>
                 </a:solidFill>
                 <a:latin typeface="Microsoft JhengHei"/>
               </a:defRPr>
             </a:pPr>
             <a:r>
-              <a:t>• 您打算一次過預繳約 HK$150,000（含徵費後約 HK$150,000.10）</a:t>
+              <a:t>第 56 保單年度 · 非保證演示</a:t>
             </a:r>
           </a:p>
         </p:txBody>
@@ -3368,8 +3373,8 @@
         </p:nvSpPr>
         <p:spPr>
           <a:xfrm>
-            <a:off x="685800" y="2487168"/>
-            <a:ext cx="7772400" cy="594360"/>
+            <a:off x="640080" y="1737360"/>
+            <a:ext cx="7863840" cy="1188720"/>
           </a:xfrm>
           <a:prstGeom prst="rect">
             <a:avLst/>
@@ -3382,16 +3387,20 @@
           </a:bodyPr>
           <a:lstStyle/>
           <a:p>
-            <a:pPr algn="l">
-              <a:defRPr sz="1800" b="0">
-                <a:solidFill>
-                  <a:srgbClr val="4A5568"/>
+            <a:pPr algn="ctr">
+              <a:defRPr sz="2400" b="1">
+                <a:solidFill>
+                  <a:srgbClr val="059669"/>
                 </a:solidFill>
                 <a:latin typeface="Microsoft JhengHei"/>
               </a:defRPr>
             </a:pPr>
             <a:r>
-              <a:t>• 每年保費及徵費於保單週年日從預繳戶口自動扣除</a:t>
+              <a:t>預期現金價值總額約 HK$3,752,770</a:t>
+            </a:r>
+            <a:br/>
+            <a:r>
+              <a:t>約為已繳總保費的 23.3 倍*</a:t>
             </a:r>
           </a:p>
         </p:txBody>
@@ -3404,8 +3413,8 @@
         </p:nvSpPr>
         <p:spPr>
           <a:xfrm>
-            <a:off x="685800" y="3145536"/>
-            <a:ext cx="7772400" cy="594360"/>
+            <a:off x="640080" y="3108960"/>
+            <a:ext cx="7863840" cy="2194560"/>
           </a:xfrm>
           <a:prstGeom prst="rect">
             <a:avLst/>
@@ -3418,88 +3427,20 @@
           </a:bodyPr>
           <a:lstStyle/>
           <a:p>
-            <a:pPr algn="l">
-              <a:defRPr sz="1800" b="0">
-                <a:solidFill>
-                  <a:srgbClr val="4A5568"/>
+            <a:pPr algn="ctr">
+              <a:defRPr sz="1600" b="0">
+                <a:solidFill>
+                  <a:srgbClr val="718590"/>
                 </a:solidFill>
                 <a:latin typeface="Microsoft JhengHei"/>
               </a:defRPr>
             </a:pPr>
             <a:r>
-              <a:t>• 基本計劃預繳餘額以保證年利率 3.50% 積存生息</a:t>
-            </a:r>
-          </a:p>
-        </p:txBody>
-      </p:sp>
-      <p:sp>
-        <p:nvSpPr>
-          <p:cNvPr id="7" name="TextBox 6"/>
-          <p:cNvSpPr txBox="1"/>
-          <p:nvPr/>
-        </p:nvSpPr>
-        <p:spPr>
-          <a:xfrm>
-            <a:off x="685800" y="3803904"/>
-            <a:ext cx="7772400" cy="594360"/>
-          </a:xfrm>
-          <a:prstGeom prst="rect">
-            <a:avLst/>
-          </a:prstGeom>
-          <a:noFill/>
-        </p:spPr>
-        <p:txBody>
-          <a:bodyPr wrap="square">
-            <a:spAutoFit/>
-          </a:bodyPr>
-          <a:lstStyle/>
-          <a:p>
-            <a:pPr algn="l">
-              <a:defRPr sz="1800" b="0">
-                <a:solidFill>
-                  <a:srgbClr val="4A5568"/>
-                </a:solidFill>
-                <a:latin typeface="Microsoft JhengHei"/>
-              </a:defRPr>
-            </a:pPr>
-            <a:r>
-              <a:t>• 第 5 個保單年度後預繳戶口餘額為 0，之後無需再繳費</a:t>
-            </a:r>
-          </a:p>
-        </p:txBody>
-      </p:sp>
-      <p:sp>
-        <p:nvSpPr>
-          <p:cNvPr id="8" name="TextBox 7"/>
-          <p:cNvSpPr txBox="1"/>
-          <p:nvPr/>
-        </p:nvSpPr>
-        <p:spPr>
-          <a:xfrm>
-            <a:off x="685800" y="4462272"/>
-            <a:ext cx="7772400" cy="594360"/>
-          </a:xfrm>
-          <a:prstGeom prst="rect">
-            <a:avLst/>
-          </a:prstGeom>
-          <a:noFill/>
-        </p:spPr>
-        <p:txBody>
-          <a:bodyPr wrap="square">
-            <a:spAutoFit/>
-          </a:bodyPr>
-          <a:lstStyle/>
-          <a:p>
-            <a:pPr algn="l">
-              <a:defRPr sz="1800" b="0">
-                <a:solidFill>
-                  <a:srgbClr val="4A5568"/>
-                </a:solidFill>
-                <a:latin typeface="Microsoft JhengHei"/>
-              </a:defRPr>
-            </a:pPr>
-            <a:r>
-              <a:t>• 提早退保或提取預繳餘額可能須付預繳保費退回費用（現行 6%）</a:t>
+              <a:t>可作退休或再傳承予第三代之長線參考。</a:t>
+            </a:r>
+            <a:br/>
+            <a:r>
+              <a:t>過往演示不代表將來；紅利可為零或調整。</a:t>
             </a:r>
           </a:p>
         </p:txBody>
@@ -3604,7 +3545,7 @@
               </a:defRPr>
             </a:pPr>
             <a:r>
-              <a:t>重要提示</a:t>
+              <a:t>預繳保費戶口</a:t>
             </a:r>
           </a:p>
         </p:txBody>
@@ -3618,7 +3559,7 @@
         <p:spPr>
           <a:xfrm>
             <a:off x="548640" y="1051560"/>
-            <a:ext cx="8046720" cy="457200"/>
+            <a:ext cx="8046720" cy="502920"/>
           </a:xfrm>
           <a:prstGeom prst="rect">
             <a:avLst/>
@@ -3640,7 +3581,7 @@
               </a:defRPr>
             </a:pPr>
             <a:r>
-              <a:t>請與爺爺充分溝通風險</a:t>
+              <a:t>配合爺爺一次過 HK$150,000</a:t>
             </a:r>
           </a:p>
         </p:txBody>
@@ -3654,7 +3595,7 @@
         <p:spPr>
           <a:xfrm>
             <a:off x="685800" y="1828800"/>
-            <a:ext cx="7772400" cy="594360"/>
+            <a:ext cx="7772400" cy="640080"/>
           </a:xfrm>
           <a:prstGeom prst="rect">
             <a:avLst/>
@@ -3668,15 +3609,15 @@
           <a:lstStyle/>
           <a:p>
             <a:pPr algn="l">
-              <a:defRPr sz="1700" b="0">
-                <a:solidFill>
-                  <a:srgbClr val="9B2C2C"/>
+              <a:defRPr sz="1800" b="0">
+                <a:solidFill>
+                  <a:srgbClr val="4A5568"/>
                 </a:solidFill>
                 <a:latin typeface="Microsoft JhengHei"/>
               </a:defRPr>
             </a:pPr>
             <a:r>
-              <a:t>• 除非有意就全期 5 年繳清保費，否則不應投保</a:t>
+              <a:t>• 預繳約 HK$150,000.10 後，每年保費於保單週年日自動扣除</a:t>
             </a:r>
           </a:p>
         </p:txBody>
@@ -3689,8 +3630,8 @@
         </p:nvSpPr>
         <p:spPr>
           <a:xfrm>
-            <a:off x="685800" y="2487168"/>
-            <a:ext cx="7772400" cy="594360"/>
+            <a:off x="685800" y="2450592"/>
+            <a:ext cx="7772400" cy="640080"/>
           </a:xfrm>
           <a:prstGeom prst="rect">
             <a:avLst/>
@@ -3704,15 +3645,15 @@
           <a:lstStyle/>
           <a:p>
             <a:pPr algn="l">
-              <a:defRPr sz="1700" b="0">
-                <a:solidFill>
-                  <a:srgbClr val="9B2C2C"/>
+              <a:defRPr sz="1800" b="0">
+                <a:solidFill>
+                  <a:srgbClr val="4A5568"/>
                 </a:solidFill>
                 <a:latin typeface="Microsoft JhengHei"/>
               </a:defRPr>
             </a:pPr>
             <a:r>
-              <a:t>• 提早退保或停止供款可能蒙受重大損失</a:t>
+              <a:t>• 預繳餘額以保證年利率 3.50% 積存，直至第 5 保單年度</a:t>
             </a:r>
           </a:p>
         </p:txBody>
@@ -3725,8 +3666,8 @@
         </p:nvSpPr>
         <p:spPr>
           <a:xfrm>
-            <a:off x="685800" y="3145536"/>
-            <a:ext cx="7772400" cy="594360"/>
+            <a:off x="685800" y="3072384"/>
+            <a:ext cx="7772400" cy="640080"/>
           </a:xfrm>
           <a:prstGeom prst="rect">
             <a:avLst/>
@@ -3740,15 +3681,15 @@
           <a:lstStyle/>
           <a:p>
             <a:pPr algn="l">
-              <a:defRPr sz="1700" b="0">
-                <a:solidFill>
-                  <a:srgbClr val="9B2C2C"/>
+              <a:defRPr sz="1800" b="0">
+                <a:solidFill>
+                  <a:srgbClr val="4A5568"/>
                 </a:solidFill>
                 <a:latin typeface="Microsoft JhengHei"/>
               </a:defRPr>
             </a:pPr>
             <a:r>
-              <a:t>• 非保證利益（週年紅利、終期紅利）可為零或調整</a:t>
+              <a:t>• 第 5 年後無需再繳費，保單繼續為孫女滾存</a:t>
             </a:r>
           </a:p>
         </p:txBody>
@@ -3761,8 +3702,8 @@
         </p:nvSpPr>
         <p:spPr>
           <a:xfrm>
-            <a:off x="685800" y="3803904"/>
-            <a:ext cx="7772400" cy="594360"/>
+            <a:off x="685800" y="3694176"/>
+            <a:ext cx="7772400" cy="640080"/>
           </a:xfrm>
           <a:prstGeom prst="rect">
             <a:avLst/>
@@ -3776,51 +3717,15 @@
           <a:lstStyle/>
           <a:p>
             <a:pPr algn="l">
-              <a:defRPr sz="1700" b="0">
-                <a:solidFill>
-                  <a:srgbClr val="9B2C2C"/>
+              <a:defRPr sz="1800" b="0">
+                <a:solidFill>
+                  <a:srgbClr val="4A5568"/>
                 </a:solidFill>
                 <a:latin typeface="Microsoft JhengHei"/>
               </a:defRPr>
             </a:pPr>
             <a:r>
-              <a:t>• 建議書有效期 30 日（2026年6月4日起）</a:t>
-            </a:r>
-          </a:p>
-        </p:txBody>
-      </p:sp>
-      <p:sp>
-        <p:nvSpPr>
-          <p:cNvPr id="9" name="TextBox 8"/>
-          <p:cNvSpPr txBox="1"/>
-          <p:nvPr/>
-        </p:nvSpPr>
-        <p:spPr>
-          <a:xfrm>
-            <a:off x="685800" y="4462272"/>
-            <a:ext cx="7772400" cy="594360"/>
-          </a:xfrm>
-          <a:prstGeom prst="rect">
-            <a:avLst/>
-          </a:prstGeom>
-          <a:noFill/>
-        </p:spPr>
-        <p:txBody>
-          <a:bodyPr wrap="square">
-            <a:spAutoFit/>
-          </a:bodyPr>
-          <a:lstStyle/>
-          <a:p>
-            <a:pPr algn="l">
-              <a:defRPr sz="1700" b="0">
-                <a:solidFill>
-                  <a:srgbClr val="9B2C2C"/>
-                </a:solidFill>
-                <a:latin typeface="Microsoft JhengHei"/>
-              </a:defRPr>
-            </a:pPr>
-            <a:r>
-              <a:t>• 此簡報僅供說明，以保單條款及正式建議書為準</a:t>
+              <a:t>• 提早退保或提取預繳餘額可能須付退回費用（現行 6%）</a:t>
             </a:r>
           </a:p>
         </p:txBody>
@@ -3834,6 +3739,255 @@
 </file>
 
 <file path=ppt/slides/slide12.xml><?xml version="1.0" encoding="utf-8"?>
+<p:sld xmlns:a="http://schemas.openxmlformats.org/drawingml/2006/main" xmlns:p="http://schemas.openxmlformats.org/presentationml/2006/main" xmlns:r="http://schemas.openxmlformats.org/officeDocument/2006/relationships">
+  <p:cSld>
+    <p:bg>
+      <p:bgPr>
+        <a:solidFill>
+          <a:srgbClr val="F0FDF4"/>
+        </a:solidFill>
+        <a:effectLst/>
+      </p:bgPr>
+    </p:bg>
+    <p:spTree>
+      <p:nvGrpSpPr>
+        <p:cNvPr id="1" name=""/>
+        <p:cNvGrpSpPr/>
+        <p:nvPr/>
+      </p:nvGrpSpPr>
+      <p:grpSpPr/>
+      <p:sp>
+        <p:nvSpPr>
+          <p:cNvPr id="2" name="Rectangle 1"/>
+          <p:cNvSpPr/>
+          <p:nvPr/>
+        </p:nvSpPr>
+        <p:spPr>
+          <a:xfrm>
+            <a:off x="0" y="0"/>
+            <a:ext cx="9144000" cy="109728"/>
+          </a:xfrm>
+          <a:prstGeom prst="rect">
+            <a:avLst/>
+          </a:prstGeom>
+          <a:solidFill>
+            <a:srgbClr val="D69E2E"/>
+          </a:solidFill>
+          <a:ln>
+            <a:noFill/>
+          </a:ln>
+        </p:spPr>
+        <p:style>
+          <a:lnRef idx="1">
+            <a:schemeClr val="accent1"/>
+          </a:lnRef>
+          <a:fillRef idx="3">
+            <a:schemeClr val="accent1"/>
+          </a:fillRef>
+          <a:effectRef idx="2">
+            <a:schemeClr val="accent1"/>
+          </a:effectRef>
+          <a:fontRef idx="minor">
+            <a:schemeClr val="lt1"/>
+          </a:fontRef>
+        </p:style>
+        <p:txBody>
+          <a:bodyPr rtlCol="0" anchor="ctr"/>
+          <a:lstStyle/>
+          <a:p>
+            <a:pPr algn="ctr"/>
+          </a:p>
+        </p:txBody>
+      </p:sp>
+      <p:sp>
+        <p:nvSpPr>
+          <p:cNvPr id="3" name="TextBox 2"/>
+          <p:cNvSpPr txBox="1"/>
+          <p:nvPr/>
+        </p:nvSpPr>
+        <p:spPr>
+          <a:xfrm>
+            <a:off x="548640" y="411480"/>
+            <a:ext cx="8046720" cy="640080"/>
+          </a:xfrm>
+          <a:prstGeom prst="rect">
+            <a:avLst/>
+          </a:prstGeom>
+          <a:noFill/>
+        </p:spPr>
+        <p:txBody>
+          <a:bodyPr wrap="square">
+            <a:spAutoFit/>
+          </a:bodyPr>
+          <a:lstStyle/>
+          <a:p>
+            <a:pPr algn="l">
+              <a:defRPr sz="3200" b="1">
+                <a:solidFill>
+                  <a:srgbClr val="1A365D"/>
+                </a:solidFill>
+                <a:latin typeface="Microsoft JhengHei"/>
+              </a:defRPr>
+            </a:pPr>
+            <a:r>
+              <a:t>重要提示</a:t>
+            </a:r>
+          </a:p>
+        </p:txBody>
+      </p:sp>
+      <p:sp>
+        <p:nvSpPr>
+          <p:cNvPr id="4" name="TextBox 3"/>
+          <p:cNvSpPr txBox="1"/>
+          <p:nvPr/>
+        </p:nvSpPr>
+        <p:spPr>
+          <a:xfrm>
+            <a:off x="685800" y="1828800"/>
+            <a:ext cx="7772400" cy="640080"/>
+          </a:xfrm>
+          <a:prstGeom prst="rect">
+            <a:avLst/>
+          </a:prstGeom>
+          <a:noFill/>
+        </p:spPr>
+        <p:txBody>
+          <a:bodyPr wrap="square">
+            <a:spAutoFit/>
+          </a:bodyPr>
+          <a:lstStyle/>
+          <a:p>
+            <a:pPr algn="l">
+              <a:defRPr sz="1700" b="0">
+                <a:solidFill>
+                  <a:srgbClr val="9B2C2C"/>
+                </a:solidFill>
+                <a:latin typeface="Microsoft JhengHei"/>
+              </a:defRPr>
+            </a:pPr>
+            <a:r>
+              <a:t>• 除非有意就全期 5 年繳清保費，否則不應投保</a:t>
+            </a:r>
+          </a:p>
+        </p:txBody>
+      </p:sp>
+      <p:sp>
+        <p:nvSpPr>
+          <p:cNvPr id="5" name="TextBox 4"/>
+          <p:cNvSpPr txBox="1"/>
+          <p:nvPr/>
+        </p:nvSpPr>
+        <p:spPr>
+          <a:xfrm>
+            <a:off x="685800" y="2450592"/>
+            <a:ext cx="7772400" cy="640080"/>
+          </a:xfrm>
+          <a:prstGeom prst="rect">
+            <a:avLst/>
+          </a:prstGeom>
+          <a:noFill/>
+        </p:spPr>
+        <p:txBody>
+          <a:bodyPr wrap="square">
+            <a:spAutoFit/>
+          </a:bodyPr>
+          <a:lstStyle/>
+          <a:p>
+            <a:pPr algn="l">
+              <a:defRPr sz="1700" b="0">
+                <a:solidFill>
+                  <a:srgbClr val="9B2C2C"/>
+                </a:solidFill>
+                <a:latin typeface="Microsoft JhengHei"/>
+              </a:defRPr>
+            </a:pPr>
+            <a:r>
+              <a:t>• 提早退保可能蒙受重大損失；非保證紅利可升可跌</a:t>
+            </a:r>
+          </a:p>
+        </p:txBody>
+      </p:sp>
+      <p:sp>
+        <p:nvSpPr>
+          <p:cNvPr id="6" name="TextBox 5"/>
+          <p:cNvSpPr txBox="1"/>
+          <p:nvPr/>
+        </p:nvSpPr>
+        <p:spPr>
+          <a:xfrm>
+            <a:off x="685800" y="3072384"/>
+            <a:ext cx="7772400" cy="640080"/>
+          </a:xfrm>
+          <a:prstGeom prst="rect">
+            <a:avLst/>
+          </a:prstGeom>
+          <a:noFill/>
+        </p:spPr>
+        <p:txBody>
+          <a:bodyPr wrap="square">
+            <a:spAutoFit/>
+          </a:bodyPr>
+          <a:lstStyle/>
+          <a:p>
+            <a:pPr algn="l">
+              <a:defRPr sz="1700" b="0">
+                <a:solidFill>
+                  <a:srgbClr val="9B2C2C"/>
+                </a:solidFill>
+                <a:latin typeface="Microsoft JhengHei"/>
+              </a:defRPr>
+            </a:pPr>
+            <a:r>
+              <a:t>• 人生階段金額僅為建議書演示，不等同保證可取回金額</a:t>
+            </a:r>
+          </a:p>
+        </p:txBody>
+      </p:sp>
+      <p:sp>
+        <p:nvSpPr>
+          <p:cNvPr id="7" name="TextBox 6"/>
+          <p:cNvSpPr txBox="1"/>
+          <p:nvPr/>
+        </p:nvSpPr>
+        <p:spPr>
+          <a:xfrm>
+            <a:off x="685800" y="3694176"/>
+            <a:ext cx="7772400" cy="640080"/>
+          </a:xfrm>
+          <a:prstGeom prst="rect">
+            <a:avLst/>
+          </a:prstGeom>
+          <a:noFill/>
+        </p:spPr>
+        <p:txBody>
+          <a:bodyPr wrap="square">
+            <a:spAutoFit/>
+          </a:bodyPr>
+          <a:lstStyle/>
+          <a:p>
+            <a:pPr algn="l">
+              <a:defRPr sz="1700" b="0">
+                <a:solidFill>
+                  <a:srgbClr val="9B2C2C"/>
+                </a:solidFill>
+                <a:latin typeface="Microsoft JhengHei"/>
+              </a:defRPr>
+            </a:pPr>
+            <a:r>
+              <a:t>• 建議書有效期 30 日（2026年6月4日起）</a:t>
+            </a:r>
+          </a:p>
+        </p:txBody>
+      </p:sp>
+    </p:spTree>
+  </p:cSld>
+  <p:clrMapOvr>
+    <a:masterClrMapping/>
+  </p:clrMapOvr>
+</p:sld>
+</file>
+
+<file path=ppt/slides/slide13.xml><?xml version="1.0" encoding="utf-8"?>
 <p:sld xmlns:a="http://schemas.openxmlformats.org/drawingml/2006/main" xmlns:p="http://schemas.openxmlformats.org/presentationml/2006/main" xmlns:r="http://schemas.openxmlformats.org/officeDocument/2006/relationships">
   <p:cSld>
     <p:bg>
@@ -3859,7 +4013,7 @@
         </p:nvSpPr>
         <p:spPr>
           <a:xfrm>
-            <a:off x="548640" y="1645920"/>
+            <a:off x="548640" y="1463040"/>
             <a:ext cx="8046720" cy="914400"/>
           </a:xfrm>
           <a:prstGeom prst="rect">
@@ -3895,8 +4049,8 @@
         </p:nvSpPr>
         <p:spPr>
           <a:xfrm>
-            <a:off x="685800" y="2926080"/>
-            <a:ext cx="7772400" cy="594360"/>
+            <a:off x="685800" y="2651760"/>
+            <a:ext cx="7772400" cy="640080"/>
           </a:xfrm>
           <a:prstGeom prst="rect">
             <a:avLst/>
@@ -3918,7 +4072,7 @@
               </a:defRPr>
             </a:pPr>
             <a:r>
-              <a:t>• 確認孫女為受保人、您為保單權益人及受益人安排</a:t>
+              <a:t>• 確認以孫女為受保人、您為保單權益人</a:t>
             </a:r>
           </a:p>
         </p:txBody>
@@ -3931,8 +4085,8 @@
         </p:nvSpPr>
         <p:spPr>
           <a:xfrm>
-            <a:off x="685800" y="3584448"/>
-            <a:ext cx="7772400" cy="594360"/>
+            <a:off x="685800" y="3273552"/>
+            <a:ext cx="7772400" cy="640080"/>
           </a:xfrm>
           <a:prstGeom prst="rect">
             <a:avLst/>
@@ -3954,7 +4108,7 @@
               </a:defRPr>
             </a:pPr>
             <a:r>
-              <a:t>• 確認一次過預繳金額及5年供款意願</a:t>
+              <a:t>• 確認一次過預繳及 5 年供款意願</a:t>
             </a:r>
           </a:p>
         </p:txBody>
@@ -3967,8 +4121,8 @@
         </p:nvSpPr>
         <p:spPr>
           <a:xfrm>
-            <a:off x="685800" y="4242816"/>
-            <a:ext cx="7772400" cy="594360"/>
+            <a:off x="685800" y="3895344"/>
+            <a:ext cx="7772400" cy="640080"/>
           </a:xfrm>
           <a:prstGeom prst="rect">
             <a:avLst/>
@@ -3990,7 +4144,7 @@
               </a:defRPr>
             </a:pPr>
             <a:r>
-              <a:t>• 完成投保申請及健康告知</a:t>
+              <a:t>• 討論各人生階段資金用途（升學、置業、成家、創業）</a:t>
             </a:r>
           </a:p>
         </p:txBody>
@@ -4003,8 +4157,8 @@
         </p:nvSpPr>
         <p:spPr>
           <a:xfrm>
-            <a:off x="685800" y="4901184"/>
-            <a:ext cx="7772400" cy="594360"/>
+            <a:off x="685800" y="4517136"/>
+            <a:ext cx="7772400" cy="640080"/>
           </a:xfrm>
           <a:prstGeom prst="rect">
             <a:avLst/>
@@ -4026,7 +4180,7 @@
               </a:defRPr>
             </a:pPr>
             <a:r>
-              <a:t>• 保單生效後，定期檢視週年紅利與保單價值</a:t>
+              <a:t>• 完成投保申請；保單生效後定期檢視紅利與保單價值</a:t>
             </a:r>
           </a:p>
         </p:txBody>
@@ -4066,7 +4220,7 @@
             </a:r>
             <a:br/>
             <a:r>
-              <a:t>建議書編號：131HK0520260604094001（中銀人壽正式建議書）</a:t>
+              <a:t>建議書編號：131HK0520260604094001</a:t>
             </a:r>
           </a:p>
         </p:txBody>
@@ -4171,7 +4325,7 @@
               </a:defRPr>
             </a:pPr>
             <a:r>
-              <a:t>爺爺的心意：為孫女鋪路未來</a:t>
+              <a:t>為什麼為孫女選擇「寰御安心環球終身」？</a:t>
             </a:r>
           </a:p>
         </p:txBody>
@@ -4185,7 +4339,7 @@
         <p:spPr>
           <a:xfrm>
             <a:off x="548640" y="1051560"/>
-            <a:ext cx="8046720" cy="457200"/>
+            <a:ext cx="8046720" cy="502920"/>
           </a:xfrm>
           <a:prstGeom prst="rect">
             <a:avLst/>
@@ -4207,7 +4361,7 @@
               </a:defRPr>
             </a:pPr>
             <a:r>
-              <a:t>Male client 60+ · 希望為 9 歲孫女建立儲蓄與保障</a:t>
+              <a:t>儲蓄 + 終身保障 + 跨代傳承，一次過預繳完成責任</a:t>
             </a:r>
           </a:p>
         </p:txBody>
@@ -4220,8 +4374,8 @@
         </p:nvSpPr>
         <p:spPr>
           <a:xfrm>
-            <a:off x="685800" y="1828800"/>
-            <a:ext cx="7772400" cy="594360"/>
+            <a:off x="685800" y="1783080"/>
+            <a:ext cx="7772400" cy="640080"/>
           </a:xfrm>
           <a:prstGeom prst="rect">
             <a:avLst/>
@@ -4235,7 +4389,7 @@
           <a:lstStyle/>
           <a:p>
             <a:pPr algn="l">
-              <a:defRPr sz="1900" b="0">
+              <a:defRPr sz="1800" b="0">
                 <a:solidFill>
                   <a:srgbClr val="4A5568"/>
                 </a:solidFill>
@@ -4243,7 +4397,7 @@
               </a:defRPr>
             </a:pPr>
             <a:r>
-              <a:t>• 您希望以一次過資金，為孫女建立長線儲蓄，減輕日後供款壓力</a:t>
+              <a:t>• 孫女儲蓄：以受保人身份投保，紅利在長年期內滾存，配合她由升學到置業的人生節奏</a:t>
             </a:r>
           </a:p>
         </p:txBody>
@@ -4256,8 +4410,8 @@
         </p:nvSpPr>
         <p:spPr>
           <a:xfrm>
-            <a:off x="685800" y="2487168"/>
-            <a:ext cx="7772400" cy="594360"/>
+            <a:off x="685800" y="2404872"/>
+            <a:ext cx="7772400" cy="640080"/>
           </a:xfrm>
           <a:prstGeom prst="rect">
             <a:avLst/>
@@ -4271,7 +4425,7 @@
           <a:lstStyle/>
           <a:p>
             <a:pPr algn="l">
-              <a:defRPr sz="1900" b="0">
+              <a:defRPr sz="1800" b="0">
                 <a:solidFill>
                   <a:srgbClr val="4A5568"/>
                 </a:solidFill>
@@ -4279,7 +4433,7 @@
               </a:defRPr>
             </a:pPr>
             <a:r>
-              <a:t>• 孫女現年 9 歲，保障年期長，時間複利可發揮更大作用</a:t>
+              <a:t>• 爺爺一次過預繳約 HK$150,000，5 年保費責任完結，無需年年操心繳費</a:t>
             </a:r>
           </a:p>
         </p:txBody>
@@ -4292,8 +4446,8 @@
         </p:nvSpPr>
         <p:spPr>
           <a:xfrm>
-            <a:off x="685800" y="3145536"/>
-            <a:ext cx="7772400" cy="594360"/>
+            <a:off x="685800" y="3026664"/>
+            <a:ext cx="7772400" cy="640080"/>
           </a:xfrm>
           <a:prstGeom prst="rect">
             <a:avLst/>
@@ -4307,7 +4461,7 @@
           <a:lstStyle/>
           <a:p>
             <a:pPr algn="l">
-              <a:defRPr sz="1900" b="0">
+              <a:defRPr sz="1800" b="0">
                 <a:solidFill>
                   <a:srgbClr val="4A5568"/>
                 </a:solidFill>
@@ -4315,7 +4469,7 @@
               </a:defRPr>
             </a:pPr>
             <a:r>
-              <a:t>• 即使爺爺不在身邊，保單仍可延續保障與財富傳承安排</a:t>
+              <a:t>• 兼備人壽保障：即使爺爺或孫女遇上人生變故，保單仍可延續安排</a:t>
             </a:r>
           </a:p>
         </p:txBody>
@@ -4328,8 +4482,8 @@
         </p:nvSpPr>
         <p:spPr>
           <a:xfrm>
-            <a:off x="685800" y="3803904"/>
-            <a:ext cx="7772400" cy="594360"/>
+            <a:off x="685800" y="3648456"/>
+            <a:ext cx="7772400" cy="640080"/>
           </a:xfrm>
           <a:prstGeom prst="rect">
             <a:avLst/>
@@ -4343,7 +4497,7 @@
           <a:lstStyle/>
           <a:p>
             <a:pPr algn="l">
-              <a:defRPr sz="1900" b="0">
+              <a:defRPr sz="1800" b="0">
                 <a:solidFill>
                   <a:srgbClr val="4A5568"/>
                 </a:solidFill>
@@ -4351,7 +4505,43 @@
               </a:defRPr>
             </a:pPr>
             <a:r>
-              <a:t>• 預繳保費後，5 年內無需再操心每年繳費</a:t>
+              <a:t>• 可更改受保人／後備受保人：日後可把保單傳給她的子女，財富跨代延續</a:t>
+            </a:r>
+          </a:p>
+        </p:txBody>
+      </p:sp>
+      <p:sp>
+        <p:nvSpPr>
+          <p:cNvPr id="9" name="TextBox 8"/>
+          <p:cNvSpPr txBox="1"/>
+          <p:nvPr/>
+        </p:nvSpPr>
+        <p:spPr>
+          <a:xfrm>
+            <a:off x="685800" y="4270248"/>
+            <a:ext cx="7772400" cy="640080"/>
+          </a:xfrm>
+          <a:prstGeom prst="rect">
+            <a:avLst/>
+          </a:prstGeom>
+          <a:noFill/>
+        </p:spPr>
+        <p:txBody>
+          <a:bodyPr wrap="square">
+            <a:spAutoFit/>
+          </a:bodyPr>
+          <a:lstStyle/>
+          <a:p>
+            <a:pPr algn="l">
+              <a:defRPr sz="1800" b="0">
+                <a:solidFill>
+                  <a:srgbClr val="4A5568"/>
+                </a:solidFill>
+                <a:latin typeface="Microsoft JhengHei"/>
+              </a:defRPr>
+            </a:pPr>
+            <a:r>
+              <a:t>• 週年紅利 + 終期紅利（非保證）：為日後提取、退保或傳承提供彈性</a:t>
             </a:r>
           </a:p>
         </p:txBody>
@@ -4456,7 +4646,7 @@
               </a:defRPr>
             </a:pPr>
             <a:r>
-              <a:t>方案概覽</a:t>
+              <a:t>爺爺的心意</a:t>
             </a:r>
           </a:p>
         </p:txBody>
@@ -4470,7 +4660,7 @@
         <p:spPr>
           <a:xfrm>
             <a:off x="548640" y="1051560"/>
-            <a:ext cx="8046720" cy="457200"/>
+            <a:ext cx="8046720" cy="502920"/>
           </a:xfrm>
           <a:prstGeom prst="rect">
             <a:avLst/>
@@ -4492,7 +4682,7 @@
               </a:defRPr>
             </a:pPr>
             <a:r>
-              <a:t>中銀集團人壽保險有限公司</a:t>
+              <a:t>60+ 男客 · 為 9 歲孫女建立專屬儲蓄保單</a:t>
             </a:r>
           </a:p>
         </p:txBody>
@@ -4506,7 +4696,7 @@
         <p:spPr>
           <a:xfrm>
             <a:off x="685800" y="1828800"/>
-            <a:ext cx="7772400" cy="594360"/>
+            <a:ext cx="7772400" cy="640080"/>
           </a:xfrm>
           <a:prstGeom prst="rect">
             <a:avLst/>
@@ -4520,7 +4710,7 @@
           <a:lstStyle/>
           <a:p>
             <a:pPr algn="l">
-              <a:defRPr sz="2000" b="0">
+              <a:defRPr sz="1900" b="0">
                 <a:solidFill>
                   <a:srgbClr val="4A5568"/>
                 </a:solidFill>
@@ -4528,7 +4718,7 @@
               </a:defRPr>
             </a:pPr>
             <a:r>
-              <a:t>• 基本計劃：寰御安心環球終身保險計劃（港元）</a:t>
+              <a:t>• 您現時有能力，希望趁孫女尚小，為她預留一筆會隨時間增長的資產</a:t>
             </a:r>
           </a:p>
         </p:txBody>
@@ -4541,8 +4731,8 @@
         </p:nvSpPr>
         <p:spPr>
           <a:xfrm>
-            <a:off x="685800" y="2487168"/>
-            <a:ext cx="7772400" cy="594360"/>
+            <a:off x="685800" y="2450592"/>
+            <a:ext cx="7772400" cy="640080"/>
           </a:xfrm>
           <a:prstGeom prst="rect">
             <a:avLst/>
@@ -4556,7 +4746,7 @@
           <a:lstStyle/>
           <a:p>
             <a:pPr algn="l">
-              <a:defRPr sz="2000" b="0">
+              <a:defRPr sz="1900" b="0">
                 <a:solidFill>
                   <a:srgbClr val="4A5568"/>
                 </a:solidFill>
@@ -4564,7 +4754,7 @@
               </a:defRPr>
             </a:pPr>
             <a:r>
-              <a:t>• 兼備人壽保障、儲蓄增值與財富傳承功能</a:t>
+              <a:t>• 保單以孫女為受保人，權益人為您；日後可按需要調整受益人及傳承安排</a:t>
             </a:r>
           </a:p>
         </p:txBody>
@@ -4577,8 +4767,8 @@
         </p:nvSpPr>
         <p:spPr>
           <a:xfrm>
-            <a:off x="685800" y="3145536"/>
-            <a:ext cx="7772400" cy="594360"/>
+            <a:off x="685800" y="3072384"/>
+            <a:ext cx="7772400" cy="640080"/>
           </a:xfrm>
           <a:prstGeom prst="rect">
             <a:avLst/>
@@ -4592,7 +4782,7 @@
           <a:lstStyle/>
           <a:p>
             <a:pPr algn="l">
-              <a:defRPr sz="2000" b="0">
+              <a:defRPr sz="1900" b="0">
                 <a:solidFill>
                   <a:srgbClr val="4A5568"/>
                 </a:solidFill>
@@ -4600,7 +4790,7 @@
               </a:defRPr>
             </a:pPr>
             <a:r>
-              <a:t>• 週年紅利（非保證）＋終期紅利（非保證）</a:t>
+              <a:t>• 重點不是短期回報，而是覆蓋她畢業、工作、結婚、育兒、買樓、創業等人生階段</a:t>
             </a:r>
           </a:p>
         </p:txBody>
@@ -4613,8 +4803,8 @@
         </p:nvSpPr>
         <p:spPr>
           <a:xfrm>
-            <a:off x="685800" y="3803904"/>
-            <a:ext cx="7772400" cy="594360"/>
+            <a:off x="685800" y="3694176"/>
+            <a:ext cx="7772400" cy="640080"/>
           </a:xfrm>
           <a:prstGeom prst="rect">
             <a:avLst/>
@@ -4628,7 +4818,7 @@
           <a:lstStyle/>
           <a:p>
             <a:pPr algn="l">
-              <a:defRPr sz="2000" b="0">
+              <a:defRPr sz="1900" b="0">
                 <a:solidFill>
                   <a:srgbClr val="4A5568"/>
                 </a:solidFill>
@@ -4636,7 +4826,7 @@
               </a:defRPr>
             </a:pPr>
             <a:r>
-              <a:t>• 保費繳費年期：5 年｜保障年期：終身</a:t>
+              <a:t>• 預繳完成後，這份保單會一直陪伴她成長，成為爺孫之間的一份具體心意</a:t>
             </a:r>
           </a:p>
         </p:txBody>
@@ -4741,58 +4931,22 @@
               </a:defRPr>
             </a:pPr>
             <a:r>
-              <a:t>受保人資料（建議書）</a:t>
-            </a:r>
-          </a:p>
-        </p:txBody>
-      </p:sp>
-      <p:sp>
-        <p:nvSpPr>
-          <p:cNvPr id="4" name="TextBox 3"/>
-          <p:cNvSpPr txBox="1"/>
-          <p:nvPr/>
-        </p:nvSpPr>
-        <p:spPr>
-          <a:xfrm>
-            <a:off x="548640" y="1051560"/>
-            <a:ext cx="8046720" cy="457200"/>
-          </a:xfrm>
-          <a:prstGeom prst="rect">
-            <a:avLst/>
-          </a:prstGeom>
-          <a:noFill/>
-        </p:spPr>
-        <p:txBody>
-          <a:bodyPr wrap="square">
-            <a:spAutoFit/>
-          </a:bodyPr>
-          <a:lstStyle/>
-          <a:p>
-            <a:pPr algn="l">
-              <a:defRPr sz="1600" b="0">
-                <a:solidFill>
-                  <a:srgbClr val="718590"/>
-                </a:solidFill>
-                <a:latin typeface="Microsoft JhengHei"/>
-              </a:defRPr>
-            </a:pPr>
-            <a:r>
-              <a:t>保單權益人：Vip 先生｜申請人</a:t>
+              <a:t>供款安排（建議書）</a:t>
             </a:r>
           </a:p>
         </p:txBody>
       </p:sp>
       <p:graphicFrame>
         <p:nvGraphicFramePr>
-          <p:cNvPr id="5" name="Table 4"/>
+          <p:cNvPr id="4" name="Table 3"/>
           <p:cNvGraphicFramePr>
             <a:graphicFrameLocks noGrp="1"/>
           </p:cNvGraphicFramePr>
           <p:nvPr/>
         </p:nvGraphicFramePr>
         <p:xfrm>
-          <a:off x="457200" y="1691640"/>
-          <a:ext cx="8229600" cy="4389120"/>
+          <a:off x="320040" y="1691640"/>
+          <a:ext cx="8503920" cy="2926080"/>
         </p:xfrm>
         <a:graphic>
           <a:graphicData uri="http://schemas.openxmlformats.org/drawingml/2006/table">
@@ -4801,17 +4955,17 @@
                 <a:tableStyleId>{5C22544A-7EE6-4342-B048-85BDC9FD1C3A}</a:tableStyleId>
               </a:tblPr>
               <a:tblGrid>
-                <a:gridCol w="4114800"/>
-                <a:gridCol w="4114800"/>
+                <a:gridCol w="4251960"/>
+                <a:gridCol w="4251960"/>
               </a:tblGrid>
-              <a:tr h="731520">
+              <a:tr h="585216">
                 <a:tc>
                   <a:txBody>
                     <a:bodyPr/>
                     <a:lstStyle/>
                     <a:p>
                       <a:pPr algn="ctr">
-                        <a:defRPr b="1" sz="1300">
+                        <a:defRPr b="1" sz="1100">
                           <a:solidFill>
                             <a:srgbClr val="FFFFFF"/>
                           </a:solidFill>
@@ -4835,7 +4989,7 @@
                     <a:lstStyle/>
                     <a:p>
                       <a:pPr algn="ctr">
-                        <a:defRPr b="1" sz="1300">
+                        <a:defRPr b="1" sz="1100">
                           <a:solidFill>
                             <a:srgbClr val="FFFFFF"/>
                           </a:solidFill>
@@ -4854,19 +5008,19 @@
                   </a:tcPr>
                 </a:tc>
               </a:tr>
-              <a:tr h="731520">
+              <a:tr h="585216">
                 <a:tc>
                   <a:txBody>
                     <a:bodyPr/>
                     <a:lstStyle/>
                     <a:p>
                       <a:pPr algn="ctr">
-                        <a:defRPr sz="1200">
+                        <a:defRPr sz="1000">
                           <a:latin typeface="Microsoft JhengHei"/>
                         </a:defRPr>
                       </a:pPr>
                       <a:r>
-                        <a:t>與您的關係</a:t>
+                        <a:t>受保人</a:t>
                       </a:r>
                     </a:p>
                   </a:txBody>
@@ -4878,31 +5032,31 @@
                     <a:lstStyle/>
                     <a:p>
                       <a:pPr algn="ctr">
-                        <a:defRPr sz="1200">
+                        <a:defRPr sz="1000">
                           <a:latin typeface="Microsoft JhengHei"/>
                         </a:defRPr>
                       </a:pPr>
                       <a:r>
-                        <a:t>孫女（擬受保人）</a:t>
+                        <a:t>孫女 · 9 歲 · 女（非吸煙）</a:t>
                       </a:r>
                     </a:p>
                   </a:txBody>
                   <a:tcPr/>
                 </a:tc>
               </a:tr>
-              <a:tr h="731520">
+              <a:tr h="585216">
                 <a:tc>
                   <a:txBody>
                     <a:bodyPr/>
                     <a:lstStyle/>
                     <a:p>
                       <a:pPr algn="ctr">
-                        <a:defRPr sz="1200">
+                        <a:defRPr sz="1000">
                           <a:latin typeface="Microsoft JhengHei"/>
                         </a:defRPr>
                       </a:pPr>
                       <a:r>
-                        <a:t>年齡 / 性別</a:t>
+                        <a:t>保費繳費年期</a:t>
                       </a:r>
                     </a:p>
                   </a:txBody>
@@ -4918,12 +5072,12 @@
                     <a:lstStyle/>
                     <a:p>
                       <a:pPr algn="ctr">
-                        <a:defRPr sz="1200">
+                        <a:defRPr sz="1000">
                           <a:latin typeface="Microsoft JhengHei"/>
                         </a:defRPr>
                       </a:pPr>
                       <a:r>
-                        <a:t>9 歲 / 女（非吸煙者）</a:t>
+                        <a:t>5 年（已繳總保費 HK$161,022）</a:t>
                       </a:r>
                     </a:p>
                   </a:txBody>
@@ -4934,19 +5088,19 @@
                   </a:tcPr>
                 </a:tc>
               </a:tr>
-              <a:tr h="731520">
+              <a:tr h="585216">
                 <a:tc>
                   <a:txBody>
                     <a:bodyPr/>
                     <a:lstStyle/>
                     <a:p>
                       <a:pPr algn="ctr">
-                        <a:defRPr sz="1200">
+                        <a:defRPr sz="1000">
                           <a:latin typeface="Microsoft JhengHei"/>
                         </a:defRPr>
                       </a:pPr>
                       <a:r>
-                        <a:t>保障年期</a:t>
+                        <a:t>爺爺一次過預繳</a:t>
                       </a:r>
                     </a:p>
                   </a:txBody>
@@ -4958,31 +5112,31 @@
                     <a:lstStyle/>
                     <a:p>
                       <a:pPr algn="ctr">
-                        <a:defRPr sz="1200">
+                        <a:defRPr sz="1000">
                           <a:latin typeface="Microsoft JhengHei"/>
                         </a:defRPr>
                       </a:pPr>
                       <a:r>
-                        <a:t>終身</a:t>
+                        <a:t>約 HK$150,000.10（含徵費）</a:t>
                       </a:r>
                     </a:p>
                   </a:txBody>
                   <a:tcPr/>
                 </a:tc>
               </a:tr>
-              <a:tr h="731520">
+              <a:tr h="585216">
                 <a:tc>
                   <a:txBody>
                     <a:bodyPr/>
                     <a:lstStyle/>
                     <a:p>
                       <a:pPr algn="ctr">
-                        <a:defRPr sz="1200">
+                        <a:defRPr sz="1000">
                           <a:latin typeface="Microsoft JhengHei"/>
                         </a:defRPr>
                       </a:pPr>
                       <a:r>
-                        <a:t>保單貨幣</a:t>
+                        <a:t>預繳戶口保證年利率</a:t>
                       </a:r>
                     </a:p>
                   </a:txBody>
@@ -4998,12 +5152,12 @@
                     <a:lstStyle/>
                     <a:p>
                       <a:pPr algn="ctr">
-                        <a:defRPr sz="1200">
+                        <a:defRPr sz="1000">
                           <a:latin typeface="Microsoft JhengHei"/>
                         </a:defRPr>
                       </a:pPr>
                       <a:r>
-                        <a:t>港元（HKD）</a:t>
+                        <a:t>3.50%</a:t>
                       </a:r>
                     </a:p>
                   </a:txBody>
@@ -5012,42 +5166,6 @@
                       <a:srgbClr val="FFFFFF"/>
                     </a:solidFill>
                   </a:tcPr>
-                </a:tc>
-              </a:tr>
-              <a:tr h="731520">
-                <a:tc>
-                  <a:txBody>
-                    <a:bodyPr/>
-                    <a:lstStyle/>
-                    <a:p>
-                      <a:pPr algn="ctr">
-                        <a:defRPr sz="1200">
-                          <a:latin typeface="Microsoft JhengHei"/>
-                        </a:defRPr>
-                      </a:pPr>
-                      <a:r>
-                        <a:t>名義金額</a:t>
-                      </a:r>
-                    </a:p>
-                  </a:txBody>
-                  <a:tcPr/>
-                </a:tc>
-                <a:tc>
-                  <a:txBody>
-                    <a:bodyPr/>
-                    <a:lstStyle/>
-                    <a:p>
-                      <a:pPr algn="ctr">
-                        <a:defRPr sz="1200">
-                          <a:latin typeface="Microsoft JhengHei"/>
-                        </a:defRPr>
-                      </a:pPr>
-                      <a:r>
-                        <a:t>161,022</a:t>
-                      </a:r>
-                    </a:p>
-                  </a:txBody>
-                  <a:tcPr/>
                 </a:tc>
               </a:tr>
             </a:tbl>
@@ -5154,7 +5272,7 @@
               </a:defRPr>
             </a:pPr>
             <a:r>
-              <a:t>供款安排：一次性預繳 HK$150,000</a:t>
+              <a:t>孫女人生階段 × 保單回報參考</a:t>
             </a:r>
           </a:p>
         </p:txBody>
@@ -5168,7 +5286,7 @@
         <p:spPr>
           <a:xfrm>
             <a:off x="548640" y="1051560"/>
-            <a:ext cx="8046720" cy="457200"/>
+            <a:ext cx="8046720" cy="502920"/>
           </a:xfrm>
           <a:prstGeom prst="rect">
             <a:avLst/>
@@ -5190,7 +5308,7 @@
               </a:defRPr>
             </a:pPr>
             <a:r>
-              <a:t>推廣：寰御安心環球終身保險計劃保費折扣（至 2026-06-30）</a:t>
+              <a:t>*非保證；含週年紅利及終期紅利。第 15 保單年度預期現金價值 HK$286,059（建議書）</a:t>
             </a:r>
           </a:p>
         </p:txBody>
@@ -5204,8 +5322,8 @@
           <p:nvPr/>
         </p:nvGraphicFramePr>
         <p:xfrm>
-          <a:off x="457200" y="1691640"/>
-          <a:ext cx="8229600" cy="4389120"/>
+          <a:off x="320040" y="1627632"/>
+          <a:ext cx="8503920" cy="4572000"/>
         </p:xfrm>
         <a:graphic>
           <a:graphicData uri="http://schemas.openxmlformats.org/drawingml/2006/table">
@@ -5214,17 +5332,20 @@
                 <a:tableStyleId>{5C22544A-7EE6-4342-B048-85BDC9FD1C3A}</a:tableStyleId>
               </a:tblPr>
               <a:tblGrid>
-                <a:gridCol w="4114800"/>
-                <a:gridCol w="4114800"/>
+                <a:gridCol w="1700784"/>
+                <a:gridCol w="1700784"/>
+                <a:gridCol w="1700784"/>
+                <a:gridCol w="1700784"/>
+                <a:gridCol w="1700784"/>
               </a:tblGrid>
-              <a:tr h="731520">
+              <a:tr h="508000">
                 <a:tc>
                   <a:txBody>
                     <a:bodyPr/>
                     <a:lstStyle/>
                     <a:p>
                       <a:pPr algn="ctr">
-                        <a:defRPr b="1" sz="1300">
+                        <a:defRPr b="1" sz="1100">
                           <a:solidFill>
                             <a:srgbClr val="FFFFFF"/>
                           </a:solidFill>
@@ -5232,7 +5353,7 @@
                         </a:defRPr>
                       </a:pPr>
                       <a:r>
-                        <a:t>項目</a:t>
+                        <a:t>人生階段</a:t>
                       </a:r>
                     </a:p>
                   </a:txBody>
@@ -5248,7 +5369,7 @@
                     <a:lstStyle/>
                     <a:p>
                       <a:pPr algn="ctr">
-                        <a:defRPr b="1" sz="1300">
+                        <a:defRPr b="1" sz="1100">
                           <a:solidFill>
                             <a:srgbClr val="FFFFFF"/>
                           </a:solidFill>
@@ -5256,7 +5377,79 @@
                         </a:defRPr>
                       </a:pPr>
                       <a:r>
-                        <a:t>金額（港元）</a:t>
+                        <a:t>孫女年齡</a:t>
+                      </a:r>
+                    </a:p>
+                  </a:txBody>
+                  <a:tcPr>
+                    <a:solidFill>
+                      <a:srgbClr val="1A365D"/>
+                    </a:solidFill>
+                  </a:tcPr>
+                </a:tc>
+                <a:tc>
+                  <a:txBody>
+                    <a:bodyPr/>
+                    <a:lstStyle/>
+                    <a:p>
+                      <a:pPr algn="ctr">
+                        <a:defRPr b="1" sz="1100">
+                          <a:solidFill>
+                            <a:srgbClr val="FFFFFF"/>
+                          </a:solidFill>
+                          <a:latin typeface="Microsoft JhengHei"/>
+                        </a:defRPr>
+                      </a:pPr>
+                      <a:r>
+                        <a:t>保單年度</a:t>
+                      </a:r>
+                    </a:p>
+                  </a:txBody>
+                  <a:tcPr>
+                    <a:solidFill>
+                      <a:srgbClr val="1A365D"/>
+                    </a:solidFill>
+                  </a:tcPr>
+                </a:tc>
+                <a:tc>
+                  <a:txBody>
+                    <a:bodyPr/>
+                    <a:lstStyle/>
+                    <a:p>
+                      <a:pPr algn="ctr">
+                        <a:defRPr b="1" sz="1100">
+                          <a:solidFill>
+                            <a:srgbClr val="FFFFFF"/>
+                          </a:solidFill>
+                          <a:latin typeface="Microsoft JhengHei"/>
+                        </a:defRPr>
+                      </a:pPr>
+                      <a:r>
+                        <a:t>預期現金價值總額*</a:t>
+                      </a:r>
+                    </a:p>
+                  </a:txBody>
+                  <a:tcPr>
+                    <a:solidFill>
+                      <a:srgbClr val="1A365D"/>
+                    </a:solidFill>
+                  </a:tcPr>
+                </a:tc>
+                <a:tc>
+                  <a:txBody>
+                    <a:bodyPr/>
+                    <a:lstStyle/>
+                    <a:p>
+                      <a:pPr algn="ctr">
+                        <a:defRPr b="1" sz="1100">
+                          <a:solidFill>
+                            <a:srgbClr val="FFFFFF"/>
+                          </a:solidFill>
+                          <a:latin typeface="Microsoft JhengHei"/>
+                        </a:defRPr>
+                      </a:pPr>
+                      <a:r>
+                        <a:t>相對已繳保費</a:t>
                       </a:r>
                     </a:p>
                   </a:txBody>
@@ -5267,19 +5460,19 @@
                   </a:tcPr>
                 </a:tc>
               </a:tr>
-              <a:tr h="731520">
+              <a:tr h="508000">
                 <a:tc>
                   <a:txBody>
                     <a:bodyPr/>
                     <a:lstStyle/>
                     <a:p>
                       <a:pPr algn="ctr">
-                        <a:defRPr sz="1200">
+                        <a:defRPr sz="1000">
                           <a:latin typeface="Microsoft JhengHei"/>
                         </a:defRPr>
                       </a:pPr>
                       <a:r>
-                        <a:t>每年保費（標準）</a:t>
+                        <a:t>供款完成 · 中學</a:t>
                       </a:r>
                     </a:p>
                   </a:txBody>
@@ -5291,31 +5484,82 @@
                     <a:lstStyle/>
                     <a:p>
                       <a:pPr algn="ctr">
-                        <a:defRPr sz="1200">
+                        <a:defRPr sz="1000">
                           <a:latin typeface="Microsoft JhengHei"/>
                         </a:defRPr>
                       </a:pPr>
                       <a:r>
-                        <a:t>32,204.40</a:t>
+                        <a:t>14 歲</a:t>
+                      </a:r>
+                    </a:p>
+                  </a:txBody>
+                  <a:tcPr/>
+                </a:tc>
+                <a:tc>
+                  <a:txBody>
+                    <a:bodyPr/>
+                    <a:lstStyle/>
+                    <a:p>
+                      <a:pPr algn="ctr">
+                        <a:defRPr sz="1000">
+                          <a:latin typeface="Microsoft JhengHei"/>
+                        </a:defRPr>
+                      </a:pPr>
+                      <a:r>
+                        <a:t>第 5 年</a:t>
+                      </a:r>
+                    </a:p>
+                  </a:txBody>
+                  <a:tcPr/>
+                </a:tc>
+                <a:tc>
+                  <a:txBody>
+                    <a:bodyPr/>
+                    <a:lstStyle/>
+                    <a:p>
+                      <a:pPr algn="ctr">
+                        <a:defRPr sz="1000">
+                          <a:latin typeface="Microsoft JhengHei"/>
+                        </a:defRPr>
+                      </a:pPr>
+                      <a:r>
+                        <a:t>HK$ 67,264</a:t>
+                      </a:r>
+                    </a:p>
+                  </a:txBody>
+                  <a:tcPr/>
+                </a:tc>
+                <a:tc>
+                  <a:txBody>
+                    <a:bodyPr/>
+                    <a:lstStyle/>
+                    <a:p>
+                      <a:pPr algn="ctr">
+                        <a:defRPr sz="1000">
+                          <a:latin typeface="Microsoft JhengHei"/>
+                        </a:defRPr>
+                      </a:pPr>
+                      <a:r>
+                        <a:t>0.42 倍</a:t>
                       </a:r>
                     </a:p>
                   </a:txBody>
                   <a:tcPr/>
                 </a:tc>
               </a:tr>
-              <a:tr h="731520">
+              <a:tr h="508000">
                 <a:tc>
                   <a:txBody>
                     <a:bodyPr/>
                     <a:lstStyle/>
                     <a:p>
                       <a:pPr algn="ctr">
-                        <a:defRPr sz="1200">
+                        <a:defRPr sz="1000">
                           <a:latin typeface="Microsoft JhengHei"/>
                         </a:defRPr>
                       </a:pPr>
                       <a:r>
-                        <a:t>5 年總保費（已繳總保費）</a:t>
+                        <a:t>升學進修（DSE／大專）</a:t>
                       </a:r>
                     </a:p>
                   </a:txBody>
@@ -5331,71 +5575,12 @@
                     <a:lstStyle/>
                     <a:p>
                       <a:pPr algn="ctr">
-                        <a:defRPr sz="1200">
+                        <a:defRPr sz="1000">
                           <a:latin typeface="Microsoft JhengHei"/>
                         </a:defRPr>
                       </a:pPr>
                       <a:r>
-                        <a:t>161,022</a:t>
-                      </a:r>
-                    </a:p>
-                  </a:txBody>
-                  <a:tcPr>
-                    <a:solidFill>
-                      <a:srgbClr val="FFFFFF"/>
-                    </a:solidFill>
-                  </a:tcPr>
-                </a:tc>
-              </a:tr>
-              <a:tr h="731520">
-                <a:tc>
-                  <a:txBody>
-                    <a:bodyPr/>
-                    <a:lstStyle/>
-                    <a:p>
-                      <a:pPr algn="ctr">
-                        <a:defRPr sz="1200">
-                          <a:latin typeface="Microsoft JhengHei"/>
-                        </a:defRPr>
-                      </a:pPr>
-                      <a:r>
-                        <a:t>優惠後預繳保費總額</a:t>
-                      </a:r>
-                    </a:p>
-                  </a:txBody>
-                  <a:tcPr/>
-                </a:tc>
-                <a:tc>
-                  <a:txBody>
-                    <a:bodyPr/>
-                    <a:lstStyle/>
-                    <a:p>
-                      <a:pPr algn="ctr">
-                        <a:defRPr sz="1200">
-                          <a:latin typeface="Microsoft JhengHei"/>
-                        </a:defRPr>
-                      </a:pPr>
-                      <a:r>
-                        <a:t>149,849.62</a:t>
-                      </a:r>
-                    </a:p>
-                  </a:txBody>
-                  <a:tcPr/>
-                </a:tc>
-              </a:tr>
-              <a:tr h="731520">
-                <a:tc>
-                  <a:txBody>
-                    <a:bodyPr/>
-                    <a:lstStyle/>
-                    <a:p>
-                      <a:pPr algn="ctr">
-                        <a:defRPr sz="1200">
-                          <a:latin typeface="Microsoft JhengHei"/>
-                        </a:defRPr>
-                      </a:pPr>
-                      <a:r>
-                        <a:t>優惠後預繳保費總額及徵費</a:t>
+                        <a:t>19 歲</a:t>
                       </a:r>
                     </a:p>
                   </a:txBody>
@@ -5411,12 +5596,54 @@
                     <a:lstStyle/>
                     <a:p>
                       <a:pPr algn="ctr">
-                        <a:defRPr sz="1200">
+                        <a:defRPr sz="1000">
                           <a:latin typeface="Microsoft JhengHei"/>
                         </a:defRPr>
                       </a:pPr>
                       <a:r>
-                        <a:t>150,000.10</a:t>
+                        <a:t>第 10 年</a:t>
+                      </a:r>
+                    </a:p>
+                  </a:txBody>
+                  <a:tcPr>
+                    <a:solidFill>
+                      <a:srgbClr val="FFFFFF"/>
+                    </a:solidFill>
+                  </a:tcPr>
+                </a:tc>
+                <a:tc>
+                  <a:txBody>
+                    <a:bodyPr/>
+                    <a:lstStyle/>
+                    <a:p>
+                      <a:pPr algn="ctr">
+                        <a:defRPr sz="1000">
+                          <a:latin typeface="Microsoft JhengHei"/>
+                        </a:defRPr>
+                      </a:pPr>
+                      <a:r>
+                        <a:t>HK$ 200,527</a:t>
+                      </a:r>
+                    </a:p>
+                  </a:txBody>
+                  <a:tcPr>
+                    <a:solidFill>
+                      <a:srgbClr val="FFFFFF"/>
+                    </a:solidFill>
+                  </a:tcPr>
+                </a:tc>
+                <a:tc>
+                  <a:txBody>
+                    <a:bodyPr/>
+                    <a:lstStyle/>
+                    <a:p>
+                      <a:pPr algn="ctr">
+                        <a:defRPr sz="1000">
+                          <a:latin typeface="Microsoft JhengHei"/>
+                        </a:defRPr>
+                      </a:pPr>
+                      <a:r>
+                        <a:t>1.25 倍</a:t>
                       </a:r>
                     </a:p>
                   </a:txBody>
@@ -5427,19 +5654,19 @@
                   </a:tcPr>
                 </a:tc>
               </a:tr>
-              <a:tr h="731520">
+              <a:tr h="508000">
                 <a:tc>
                   <a:txBody>
                     <a:bodyPr/>
                     <a:lstStyle/>
                     <a:p>
                       <a:pPr algn="ctr">
-                        <a:defRPr sz="1200">
+                        <a:defRPr sz="1000">
                           <a:latin typeface="Microsoft JhengHei"/>
                         </a:defRPr>
                       </a:pPr>
                       <a:r>
-                        <a:t>預繳保費戶口保證年利率</a:t>
+                        <a:t>大學畢業 · 初入職場</a:t>
                       </a:r>
                     </a:p>
                   </a:txBody>
@@ -5451,16 +5678,562 @@
                     <a:lstStyle/>
                     <a:p>
                       <a:pPr algn="ctr">
-                        <a:defRPr sz="1200">
+                        <a:defRPr sz="1000">
                           <a:latin typeface="Microsoft JhengHei"/>
                         </a:defRPr>
                       </a:pPr>
                       <a:r>
-                        <a:t>3.50%</a:t>
+                        <a:t>24 歲</a:t>
                       </a:r>
                     </a:p>
                   </a:txBody>
                   <a:tcPr/>
+                </a:tc>
+                <a:tc>
+                  <a:txBody>
+                    <a:bodyPr/>
+                    <a:lstStyle/>
+                    <a:p>
+                      <a:pPr algn="ctr">
+                        <a:defRPr sz="1000">
+                          <a:latin typeface="Microsoft JhengHei"/>
+                        </a:defRPr>
+                      </a:pPr>
+                      <a:r>
+                        <a:t>第 15 年</a:t>
+                      </a:r>
+                    </a:p>
+                  </a:txBody>
+                  <a:tcPr/>
+                </a:tc>
+                <a:tc>
+                  <a:txBody>
+                    <a:bodyPr/>
+                    <a:lstStyle/>
+                    <a:p>
+                      <a:pPr algn="ctr">
+                        <a:defRPr sz="1000">
+                          <a:latin typeface="Microsoft JhengHei"/>
+                        </a:defRPr>
+                      </a:pPr>
+                      <a:r>
+                        <a:t>HK$ 286,059</a:t>
+                      </a:r>
+                    </a:p>
+                  </a:txBody>
+                  <a:tcPr/>
+                </a:tc>
+                <a:tc>
+                  <a:txBody>
+                    <a:bodyPr/>
+                    <a:lstStyle/>
+                    <a:p>
+                      <a:pPr algn="ctr">
+                        <a:defRPr sz="1000">
+                          <a:latin typeface="Microsoft JhengHei"/>
+                        </a:defRPr>
+                      </a:pPr>
+                      <a:r>
+                        <a:t>1.78 倍</a:t>
+                      </a:r>
+                    </a:p>
+                  </a:txBody>
+                  <a:tcPr/>
+                </a:tc>
+              </a:tr>
+              <a:tr h="508000">
+                <a:tc>
+                  <a:txBody>
+                    <a:bodyPr/>
+                    <a:lstStyle/>
+                    <a:p>
+                      <a:pPr algn="ctr">
+                        <a:defRPr sz="1000">
+                          <a:latin typeface="Microsoft JhengHei"/>
+                        </a:defRPr>
+                      </a:pPr>
+                      <a:r>
+                        <a:t>事業穩定 · 置業首期</a:t>
+                      </a:r>
+                    </a:p>
+                  </a:txBody>
+                  <a:tcPr>
+                    <a:solidFill>
+                      <a:srgbClr val="FFFFFF"/>
+                    </a:solidFill>
+                  </a:tcPr>
+                </a:tc>
+                <a:tc>
+                  <a:txBody>
+                    <a:bodyPr/>
+                    <a:lstStyle/>
+                    <a:p>
+                      <a:pPr algn="ctr">
+                        <a:defRPr sz="1000">
+                          <a:latin typeface="Microsoft JhengHei"/>
+                        </a:defRPr>
+                      </a:pPr>
+                      <a:r>
+                        <a:t>29 歲</a:t>
+                      </a:r>
+                    </a:p>
+                  </a:txBody>
+                  <a:tcPr>
+                    <a:solidFill>
+                      <a:srgbClr val="FFFFFF"/>
+                    </a:solidFill>
+                  </a:tcPr>
+                </a:tc>
+                <a:tc>
+                  <a:txBody>
+                    <a:bodyPr/>
+                    <a:lstStyle/>
+                    <a:p>
+                      <a:pPr algn="ctr">
+                        <a:defRPr sz="1000">
+                          <a:latin typeface="Microsoft JhengHei"/>
+                        </a:defRPr>
+                      </a:pPr>
+                      <a:r>
+                        <a:t>第 20 年</a:t>
+                      </a:r>
+                    </a:p>
+                  </a:txBody>
+                  <a:tcPr>
+                    <a:solidFill>
+                      <a:srgbClr val="FFFFFF"/>
+                    </a:solidFill>
+                  </a:tcPr>
+                </a:tc>
+                <a:tc>
+                  <a:txBody>
+                    <a:bodyPr/>
+                    <a:lstStyle/>
+                    <a:p>
+                      <a:pPr algn="ctr">
+                        <a:defRPr sz="1000">
+                          <a:latin typeface="Microsoft JhengHei"/>
+                        </a:defRPr>
+                      </a:pPr>
+                      <a:r>
+                        <a:t>HK$ 434,249</a:t>
+                      </a:r>
+                    </a:p>
+                  </a:txBody>
+                  <a:tcPr>
+                    <a:solidFill>
+                      <a:srgbClr val="FFFFFF"/>
+                    </a:solidFill>
+                  </a:tcPr>
+                </a:tc>
+                <a:tc>
+                  <a:txBody>
+                    <a:bodyPr/>
+                    <a:lstStyle/>
+                    <a:p>
+                      <a:pPr algn="ctr">
+                        <a:defRPr sz="1000">
+                          <a:latin typeface="Microsoft JhengHei"/>
+                        </a:defRPr>
+                      </a:pPr>
+                      <a:r>
+                        <a:t>2.70 倍</a:t>
+                      </a:r>
+                    </a:p>
+                  </a:txBody>
+                  <a:tcPr>
+                    <a:solidFill>
+                      <a:srgbClr val="FFFFFF"/>
+                    </a:solidFill>
+                  </a:tcPr>
+                </a:tc>
+              </a:tr>
+              <a:tr h="508000">
+                <a:tc>
+                  <a:txBody>
+                    <a:bodyPr/>
+                    <a:lstStyle/>
+                    <a:p>
+                      <a:pPr algn="ctr">
+                        <a:defRPr sz="1000">
+                          <a:latin typeface="Microsoft JhengHei"/>
+                        </a:defRPr>
+                      </a:pPr>
+                      <a:r>
+                        <a:t>結婚成家</a:t>
+                      </a:r>
+                    </a:p>
+                  </a:txBody>
+                  <a:tcPr/>
+                </a:tc>
+                <a:tc>
+                  <a:txBody>
+                    <a:bodyPr/>
+                    <a:lstStyle/>
+                    <a:p>
+                      <a:pPr algn="ctr">
+                        <a:defRPr sz="1000">
+                          <a:latin typeface="Microsoft JhengHei"/>
+                        </a:defRPr>
+                      </a:pPr>
+                      <a:r>
+                        <a:t>34 歲</a:t>
+                      </a:r>
+                    </a:p>
+                  </a:txBody>
+                  <a:tcPr/>
+                </a:tc>
+                <a:tc>
+                  <a:txBody>
+                    <a:bodyPr/>
+                    <a:lstStyle/>
+                    <a:p>
+                      <a:pPr algn="ctr">
+                        <a:defRPr sz="1000">
+                          <a:latin typeface="Microsoft JhengHei"/>
+                        </a:defRPr>
+                      </a:pPr>
+                      <a:r>
+                        <a:t>第 25 年</a:t>
+                      </a:r>
+                    </a:p>
+                  </a:txBody>
+                  <a:tcPr/>
+                </a:tc>
+                <a:tc>
+                  <a:txBody>
+                    <a:bodyPr/>
+                    <a:lstStyle/>
+                    <a:p>
+                      <a:pPr algn="ctr">
+                        <a:defRPr sz="1000">
+                          <a:latin typeface="Microsoft JhengHei"/>
+                        </a:defRPr>
+                      </a:pPr>
+                      <a:r>
+                        <a:t>HK$ 606,259</a:t>
+                      </a:r>
+                    </a:p>
+                  </a:txBody>
+                  <a:tcPr/>
+                </a:tc>
+                <a:tc>
+                  <a:txBody>
+                    <a:bodyPr/>
+                    <a:lstStyle/>
+                    <a:p>
+                      <a:pPr algn="ctr">
+                        <a:defRPr sz="1000">
+                          <a:latin typeface="Microsoft JhengHei"/>
+                        </a:defRPr>
+                      </a:pPr>
+                      <a:r>
+                        <a:t>3.77 倍</a:t>
+                      </a:r>
+                    </a:p>
+                  </a:txBody>
+                  <a:tcPr/>
+                </a:tc>
+              </a:tr>
+              <a:tr h="508000">
+                <a:tc>
+                  <a:txBody>
+                    <a:bodyPr/>
+                    <a:lstStyle/>
+                    <a:p>
+                      <a:pPr algn="ctr">
+                        <a:defRPr sz="1000">
+                          <a:latin typeface="Microsoft JhengHei"/>
+                        </a:defRPr>
+                      </a:pPr>
+                      <a:r>
+                        <a:t>育兒 · 家庭責任</a:t>
+                      </a:r>
+                    </a:p>
+                  </a:txBody>
+                  <a:tcPr>
+                    <a:solidFill>
+                      <a:srgbClr val="FFFFFF"/>
+                    </a:solidFill>
+                  </a:tcPr>
+                </a:tc>
+                <a:tc>
+                  <a:txBody>
+                    <a:bodyPr/>
+                    <a:lstStyle/>
+                    <a:p>
+                      <a:pPr algn="ctr">
+                        <a:defRPr sz="1000">
+                          <a:latin typeface="Microsoft JhengHei"/>
+                        </a:defRPr>
+                      </a:pPr>
+                      <a:r>
+                        <a:t>39 歲</a:t>
+                      </a:r>
+                    </a:p>
+                  </a:txBody>
+                  <a:tcPr>
+                    <a:solidFill>
+                      <a:srgbClr val="FFFFFF"/>
+                    </a:solidFill>
+                  </a:tcPr>
+                </a:tc>
+                <a:tc>
+                  <a:txBody>
+                    <a:bodyPr/>
+                    <a:lstStyle/>
+                    <a:p>
+                      <a:pPr algn="ctr">
+                        <a:defRPr sz="1000">
+                          <a:latin typeface="Microsoft JhengHei"/>
+                        </a:defRPr>
+                      </a:pPr>
+                      <a:r>
+                        <a:t>第 30 年</a:t>
+                      </a:r>
+                    </a:p>
+                  </a:txBody>
+                  <a:tcPr>
+                    <a:solidFill>
+                      <a:srgbClr val="FFFFFF"/>
+                    </a:solidFill>
+                  </a:tcPr>
+                </a:tc>
+                <a:tc>
+                  <a:txBody>
+                    <a:bodyPr/>
+                    <a:lstStyle/>
+                    <a:p>
+                      <a:pPr algn="ctr">
+                        <a:defRPr sz="1000">
+                          <a:latin typeface="Microsoft JhengHei"/>
+                        </a:defRPr>
+                      </a:pPr>
+                      <a:r>
+                        <a:t>HK$ 825,491</a:t>
+                      </a:r>
+                    </a:p>
+                  </a:txBody>
+                  <a:tcPr>
+                    <a:solidFill>
+                      <a:srgbClr val="FFFFFF"/>
+                    </a:solidFill>
+                  </a:tcPr>
+                </a:tc>
+                <a:tc>
+                  <a:txBody>
+                    <a:bodyPr/>
+                    <a:lstStyle/>
+                    <a:p>
+                      <a:pPr algn="ctr">
+                        <a:defRPr sz="1000">
+                          <a:latin typeface="Microsoft JhengHei"/>
+                        </a:defRPr>
+                      </a:pPr>
+                      <a:r>
+                        <a:t>5.13 倍</a:t>
+                      </a:r>
+                    </a:p>
+                  </a:txBody>
+                  <a:tcPr>
+                    <a:solidFill>
+                      <a:srgbClr val="FFFFFF"/>
+                    </a:solidFill>
+                  </a:tcPr>
+                </a:tc>
+              </a:tr>
+              <a:tr h="508000">
+                <a:tc>
+                  <a:txBody>
+                    <a:bodyPr/>
+                    <a:lstStyle/>
+                    <a:p>
+                      <a:pPr algn="ctr">
+                        <a:defRPr sz="1000">
+                          <a:latin typeface="Microsoft JhengHei"/>
+                        </a:defRPr>
+                      </a:pPr>
+                      <a:r>
+                        <a:t>事業發展 · 創業支援</a:t>
+                      </a:r>
+                    </a:p>
+                  </a:txBody>
+                  <a:tcPr/>
+                </a:tc>
+                <a:tc>
+                  <a:txBody>
+                    <a:bodyPr/>
+                    <a:lstStyle/>
+                    <a:p>
+                      <a:pPr algn="ctr">
+                        <a:defRPr sz="1000">
+                          <a:latin typeface="Microsoft JhengHei"/>
+                        </a:defRPr>
+                      </a:pPr>
+                      <a:r>
+                        <a:t>44 歲</a:t>
+                      </a:r>
+                    </a:p>
+                  </a:txBody>
+                  <a:tcPr/>
+                </a:tc>
+                <a:tc>
+                  <a:txBody>
+                    <a:bodyPr/>
+                    <a:lstStyle/>
+                    <a:p>
+                      <a:pPr algn="ctr">
+                        <a:defRPr sz="1000">
+                          <a:latin typeface="Microsoft JhengHei"/>
+                        </a:defRPr>
+                      </a:pPr>
+                      <a:r>
+                        <a:t>第 35 年</a:t>
+                      </a:r>
+                    </a:p>
+                  </a:txBody>
+                  <a:tcPr/>
+                </a:tc>
+                <a:tc>
+                  <a:txBody>
+                    <a:bodyPr/>
+                    <a:lstStyle/>
+                    <a:p>
+                      <a:pPr algn="ctr">
+                        <a:defRPr sz="1000">
+                          <a:latin typeface="Microsoft JhengHei"/>
+                        </a:defRPr>
+                      </a:pPr>
+                      <a:r>
+                        <a:t>HK$ 1,104,542</a:t>
+                      </a:r>
+                    </a:p>
+                  </a:txBody>
+                  <a:tcPr/>
+                </a:tc>
+                <a:tc>
+                  <a:txBody>
+                    <a:bodyPr/>
+                    <a:lstStyle/>
+                    <a:p>
+                      <a:pPr algn="ctr">
+                        <a:defRPr sz="1000">
+                          <a:latin typeface="Microsoft JhengHei"/>
+                        </a:defRPr>
+                      </a:pPr>
+                      <a:r>
+                        <a:t>6.86 倍</a:t>
+                      </a:r>
+                    </a:p>
+                  </a:txBody>
+                  <a:tcPr/>
+                </a:tc>
+              </a:tr>
+              <a:tr h="508000">
+                <a:tc>
+                  <a:txBody>
+                    <a:bodyPr/>
+                    <a:lstStyle/>
+                    <a:p>
+                      <a:pPr algn="ctr">
+                        <a:defRPr sz="1000">
+                          <a:latin typeface="Microsoft JhengHei"/>
+                        </a:defRPr>
+                      </a:pPr>
+                      <a:r>
+                        <a:t>退休規劃參考</a:t>
+                      </a:r>
+                    </a:p>
+                  </a:txBody>
+                  <a:tcPr>
+                    <a:solidFill>
+                      <a:srgbClr val="FFFFFF"/>
+                    </a:solidFill>
+                  </a:tcPr>
+                </a:tc>
+                <a:tc>
+                  <a:txBody>
+                    <a:bodyPr/>
+                    <a:lstStyle/>
+                    <a:p>
+                      <a:pPr algn="ctr">
+                        <a:defRPr sz="1000">
+                          <a:latin typeface="Microsoft JhengHei"/>
+                        </a:defRPr>
+                      </a:pPr>
+                      <a:r>
+                        <a:t>65 歲</a:t>
+                      </a:r>
+                    </a:p>
+                  </a:txBody>
+                  <a:tcPr>
+                    <a:solidFill>
+                      <a:srgbClr val="FFFFFF"/>
+                    </a:solidFill>
+                  </a:tcPr>
+                </a:tc>
+                <a:tc>
+                  <a:txBody>
+                    <a:bodyPr/>
+                    <a:lstStyle/>
+                    <a:p>
+                      <a:pPr algn="ctr">
+                        <a:defRPr sz="1000">
+                          <a:latin typeface="Microsoft JhengHei"/>
+                        </a:defRPr>
+                      </a:pPr>
+                      <a:r>
+                        <a:t>第 56 年</a:t>
+                      </a:r>
+                    </a:p>
+                  </a:txBody>
+                  <a:tcPr>
+                    <a:solidFill>
+                      <a:srgbClr val="FFFFFF"/>
+                    </a:solidFill>
+                  </a:tcPr>
+                </a:tc>
+                <a:tc>
+                  <a:txBody>
+                    <a:bodyPr/>
+                    <a:lstStyle/>
+                    <a:p>
+                      <a:pPr algn="ctr">
+                        <a:defRPr sz="1000">
+                          <a:latin typeface="Microsoft JhengHei"/>
+                        </a:defRPr>
+                      </a:pPr>
+                      <a:r>
+                        <a:t>HK$ 3,752,770</a:t>
+                      </a:r>
+                    </a:p>
+                  </a:txBody>
+                  <a:tcPr>
+                    <a:solidFill>
+                      <a:srgbClr val="FFFFFF"/>
+                    </a:solidFill>
+                  </a:tcPr>
+                </a:tc>
+                <a:tc>
+                  <a:txBody>
+                    <a:bodyPr/>
+                    <a:lstStyle/>
+                    <a:p>
+                      <a:pPr algn="ctr">
+                        <a:defRPr sz="1000">
+                          <a:latin typeface="Microsoft JhengHei"/>
+                        </a:defRPr>
+                      </a:pPr>
+                      <a:r>
+                        <a:t>23.31 倍</a:t>
+                      </a:r>
+                    </a:p>
+                  </a:txBody>
+                  <a:tcPr>
+                    <a:solidFill>
+                      <a:srgbClr val="FFFFFF"/>
+                    </a:solidFill>
+                  </a:tcPr>
                 </a:tc>
               </a:tr>
             </a:tbl>
@@ -5567,7 +6340,7 @@
               </a:defRPr>
             </a:pPr>
             <a:r>
-              <a:t>為什麼 9 歲開始特別合適？</a:t>
+              <a:t>各人生階段，這筆資金可以支援什麼？</a:t>
             </a:r>
           </a:p>
         </p:txBody>
@@ -5581,7 +6354,7 @@
         <p:spPr>
           <a:xfrm>
             <a:off x="548640" y="1051560"/>
-            <a:ext cx="8046720" cy="457200"/>
+            <a:ext cx="8046720" cy="502920"/>
           </a:xfrm>
           <a:prstGeom prst="rect">
             <a:avLst/>
@@ -5603,7 +6376,7 @@
               </a:defRPr>
             </a:pPr>
             <a:r>
-              <a:t>長線規劃角度</a:t>
+              <a:t>數字來自建議書「說明摘要」；實際提取須符合保單條款</a:t>
             </a:r>
           </a:p>
         </p:txBody>
@@ -5616,8 +6389,8 @@
         </p:nvSpPr>
         <p:spPr>
           <a:xfrm>
-            <a:off x="685800" y="1828800"/>
-            <a:ext cx="7772400" cy="594360"/>
+            <a:off x="685800" y="1719072"/>
+            <a:ext cx="7772400" cy="640080"/>
           </a:xfrm>
           <a:prstGeom prst="rect">
             <a:avLst/>
@@ -5631,7 +6404,7 @@
           <a:lstStyle/>
           <a:p>
             <a:pPr algn="l">
-              <a:defRPr sz="2000" b="0">
+              <a:defRPr sz="1700" b="0">
                 <a:solidFill>
                   <a:srgbClr val="4A5568"/>
                 </a:solidFill>
@@ -5639,7 +6412,7 @@
               </a:defRPr>
             </a:pPr>
             <a:r>
-              <a:t>• 供款期僅 5 年，爺爺在退休前後可一次過完成責任</a:t>
+              <a:t>• 19 歲（第 10 年）約 HK$200,527：DSE 後升學、大專生活費或進修</a:t>
             </a:r>
           </a:p>
         </p:txBody>
@@ -5652,8 +6425,8 @@
         </p:nvSpPr>
         <p:spPr>
           <a:xfrm>
-            <a:off x="685800" y="2487168"/>
-            <a:ext cx="7772400" cy="594360"/>
+            <a:off x="685800" y="2340864"/>
+            <a:ext cx="7772400" cy="640080"/>
           </a:xfrm>
           <a:prstGeom prst="rect">
             <a:avLst/>
@@ -5667,7 +6440,7 @@
           <a:lstStyle/>
           <a:p>
             <a:pPr algn="l">
-              <a:defRPr sz="2000" b="0">
+              <a:defRPr sz="1700" b="0">
                 <a:solidFill>
                   <a:srgbClr val="4A5568"/>
                 </a:solidFill>
@@ -5675,7 +6448,7 @@
               </a:defRPr>
             </a:pPr>
             <a:r>
-              <a:t>• 孫女仍有很長人生路，非保證紅利有較長時間滾存</a:t>
+              <a:t>• 24 歲（第 15 年）約 HK$286,059：大學畢業、初入職或小型創業起步</a:t>
             </a:r>
           </a:p>
         </p:txBody>
@@ -5688,8 +6461,8 @@
         </p:nvSpPr>
         <p:spPr>
           <a:xfrm>
-            <a:off x="685800" y="3145536"/>
-            <a:ext cx="7772400" cy="594360"/>
+            <a:off x="685800" y="2962656"/>
+            <a:ext cx="7772400" cy="640080"/>
           </a:xfrm>
           <a:prstGeom prst="rect">
             <a:avLst/>
@@ -5703,7 +6476,7 @@
           <a:lstStyle/>
           <a:p>
             <a:pPr algn="l">
-              <a:defRPr sz="2000" b="0">
+              <a:defRPr sz="1700" b="0">
                 <a:solidFill>
                   <a:srgbClr val="4A5568"/>
                 </a:solidFill>
@@ -5711,7 +6484,7 @@
               </a:defRPr>
             </a:pPr>
             <a:r>
-              <a:t>• 可預留「更改受保人」「後備受保人」作日後傳承</a:t>
+              <a:t>• 29 歲（第 20 年）約 HK$434,249：事業穩定、買樓首期或進修專業資格</a:t>
             </a:r>
           </a:p>
         </p:txBody>
@@ -5724,8 +6497,8 @@
         </p:nvSpPr>
         <p:spPr>
           <a:xfrm>
-            <a:off x="685800" y="3803904"/>
-            <a:ext cx="7772400" cy="594360"/>
+            <a:off x="685800" y="3584448"/>
+            <a:ext cx="7772400" cy="640080"/>
           </a:xfrm>
           <a:prstGeom prst="rect">
             <a:avLst/>
@@ -5739,7 +6512,7 @@
           <a:lstStyle/>
           <a:p>
             <a:pPr algn="l">
-              <a:defRPr sz="2000" b="0">
+              <a:defRPr sz="1700" b="0">
                 <a:solidFill>
                   <a:srgbClr val="4A5568"/>
                 </a:solidFill>
@@ -5747,7 +6520,79 @@
               </a:defRPr>
             </a:pPr>
             <a:r>
-              <a:t>• 日後孫女長大，可按需要作保單分拆或貨幣轉換（如適用）</a:t>
+              <a:t>• 34 歲（第 25 年）約 HK$606,259：結婚、新婚置業或家庭開支</a:t>
+            </a:r>
+          </a:p>
+        </p:txBody>
+      </p:sp>
+      <p:sp>
+        <p:nvSpPr>
+          <p:cNvPr id="9" name="TextBox 8"/>
+          <p:cNvSpPr txBox="1"/>
+          <p:nvPr/>
+        </p:nvSpPr>
+        <p:spPr>
+          <a:xfrm>
+            <a:off x="685800" y="4206240"/>
+            <a:ext cx="7772400" cy="640080"/>
+          </a:xfrm>
+          <a:prstGeom prst="rect">
+            <a:avLst/>
+          </a:prstGeom>
+          <a:noFill/>
+        </p:spPr>
+        <p:txBody>
+          <a:bodyPr wrap="square">
+            <a:spAutoFit/>
+          </a:bodyPr>
+          <a:lstStyle/>
+          <a:p>
+            <a:pPr algn="l">
+              <a:defRPr sz="1700" b="0">
+                <a:solidFill>
+                  <a:srgbClr val="4A5568"/>
+                </a:solidFill>
+                <a:latin typeface="Microsoft JhengHei"/>
+              </a:defRPr>
+            </a:pPr>
+            <a:r>
+              <a:t>• 39 歲（第 30 年）約 HK$825,491：育兒、子女教育或家庭醫療儲備</a:t>
+            </a:r>
+          </a:p>
+        </p:txBody>
+      </p:sp>
+      <p:sp>
+        <p:nvSpPr>
+          <p:cNvPr id="10" name="TextBox 9"/>
+          <p:cNvSpPr txBox="1"/>
+          <p:nvPr/>
+        </p:nvSpPr>
+        <p:spPr>
+          <a:xfrm>
+            <a:off x="685800" y="4828032"/>
+            <a:ext cx="7772400" cy="640080"/>
+          </a:xfrm>
+          <a:prstGeom prst="rect">
+            <a:avLst/>
+          </a:prstGeom>
+          <a:noFill/>
+        </p:spPr>
+        <p:txBody>
+          <a:bodyPr wrap="square">
+            <a:spAutoFit/>
+          </a:bodyPr>
+          <a:lstStyle/>
+          <a:p>
+            <a:pPr algn="l">
+              <a:defRPr sz="1700" b="0">
+                <a:solidFill>
+                  <a:srgbClr val="4A5568"/>
+                </a:solidFill>
+                <a:latin typeface="Microsoft JhengHei"/>
+              </a:defRPr>
+            </a:pPr>
+            <a:r>
+              <a:t>• 44 歲（第 35 年）約 HK$1,106,259：事業擴張、創業周轉或進一步置業</a:t>
             </a:r>
           </a:p>
         </p:txBody>
@@ -5852,7 +6697,7 @@
               </a:defRPr>
             </a:pPr>
             <a:r>
-              <a:t>計劃重點（與儲蓄＋傳承相關）</a:t>
+              <a:t>重點參考：第 15 保單年度</a:t>
             </a:r>
           </a:p>
         </p:txBody>
@@ -5865,8 +6710,8 @@
         </p:nvSpPr>
         <p:spPr>
           <a:xfrm>
-            <a:off x="685800" y="1783080"/>
-            <a:ext cx="7772400" cy="594360"/>
+            <a:off x="548640" y="1051560"/>
+            <a:ext cx="8046720" cy="502920"/>
           </a:xfrm>
           <a:prstGeom prst="rect">
             <a:avLst/>
@@ -5880,15 +6725,15 @@
           <a:lstStyle/>
           <a:p>
             <a:pPr algn="l">
-              <a:defRPr sz="1700" b="0">
-                <a:solidFill>
-                  <a:srgbClr val="4A5568"/>
+              <a:defRPr sz="1600" b="0">
+                <a:solidFill>
+                  <a:srgbClr val="718590"/>
                 </a:solidFill>
                 <a:latin typeface="Microsoft JhengHei"/>
               </a:defRPr>
             </a:pPr>
             <a:r>
-              <a:t>• 週年紅利（非保證）：可積存生息或提取</a:t>
+              <a:t>孫女約 24 歲 · 大學畢業／初入職場</a:t>
             </a:r>
           </a:p>
         </p:txBody>
@@ -5901,8 +6746,8 @@
         </p:nvSpPr>
         <p:spPr>
           <a:xfrm>
-            <a:off x="685800" y="2441448"/>
-            <a:ext cx="7772400" cy="594360"/>
+            <a:off x="594360" y="1691640"/>
+            <a:ext cx="7955279" cy="1280160"/>
           </a:xfrm>
           <a:prstGeom prst="rect">
             <a:avLst/>
@@ -5915,16 +6760,20 @@
           </a:bodyPr>
           <a:lstStyle/>
           <a:p>
-            <a:pPr algn="l">
-              <a:defRPr sz="1700" b="0">
-                <a:solidFill>
-                  <a:srgbClr val="4A5568"/>
+            <a:pPr algn="ctr">
+              <a:defRPr sz="3600" b="1">
+                <a:solidFill>
+                  <a:srgbClr val="059669"/>
                 </a:solidFill>
                 <a:latin typeface="Microsoft JhengHei"/>
               </a:defRPr>
             </a:pPr>
             <a:r>
-              <a:t>• 終期紅利（非保證）：退保或身故時可獲派</a:t>
+              <a:t>預期現金價值總額</a:t>
+            </a:r>
+            <a:br/>
+            <a:r>
+              <a:t>HK$ 286,059</a:t>
             </a:r>
           </a:p>
         </p:txBody>
@@ -5937,8 +6786,8 @@
         </p:nvSpPr>
         <p:spPr>
           <a:xfrm>
-            <a:off x="685800" y="3099816"/>
-            <a:ext cx="7772400" cy="594360"/>
+            <a:off x="594360" y="3063240"/>
+            <a:ext cx="7955279" cy="2560320"/>
           </a:xfrm>
           <a:prstGeom prst="rect">
             <a:avLst/>
@@ -5951,7 +6800,7 @@
           </a:bodyPr>
           <a:lstStyle/>
           <a:p>
-            <a:pPr algn="l">
+            <a:pPr algn="ctr">
               <a:defRPr sz="1700" b="0">
                 <a:solidFill>
                   <a:srgbClr val="4A5568"/>
@@ -5960,115 +6809,20 @@
               </a:defRPr>
             </a:pPr>
             <a:r>
-              <a:t>• 更改受保人：可把保障延續予下一代</a:t>
-            </a:r>
-          </a:p>
-        </p:txBody>
-      </p:sp>
-      <p:sp>
-        <p:nvSpPr>
-          <p:cNvPr id="7" name="TextBox 6"/>
-          <p:cNvSpPr txBox="1"/>
-          <p:nvPr/>
-        </p:nvSpPr>
-        <p:spPr>
-          <a:xfrm>
-            <a:off x="685800" y="3758184"/>
-            <a:ext cx="7772400" cy="594360"/>
-          </a:xfrm>
-          <a:prstGeom prst="rect">
-            <a:avLst/>
-          </a:prstGeom>
-          <a:noFill/>
-        </p:spPr>
-        <p:txBody>
-          <a:bodyPr wrap="square">
-            <a:spAutoFit/>
-          </a:bodyPr>
-          <a:lstStyle/>
-          <a:p>
-            <a:pPr algn="l">
-              <a:defRPr sz="1700" b="0">
-                <a:solidFill>
-                  <a:srgbClr val="4A5568"/>
-                </a:solidFill>
-                <a:latin typeface="Microsoft JhengHei"/>
-              </a:defRPr>
-            </a:pPr>
-            <a:r>
-              <a:t>• 後備受保人：現受保人身故後，可指定後備受保人承接</a:t>
-            </a:r>
-          </a:p>
-        </p:txBody>
-      </p:sp>
-      <p:sp>
-        <p:nvSpPr>
-          <p:cNvPr id="8" name="TextBox 7"/>
-          <p:cNvSpPr txBox="1"/>
-          <p:nvPr/>
-        </p:nvSpPr>
-        <p:spPr>
-          <a:xfrm>
-            <a:off x="685800" y="4416552"/>
-            <a:ext cx="7772400" cy="594360"/>
-          </a:xfrm>
-          <a:prstGeom prst="rect">
-            <a:avLst/>
-          </a:prstGeom>
-          <a:noFill/>
-        </p:spPr>
-        <p:txBody>
-          <a:bodyPr wrap="square">
-            <a:spAutoFit/>
-          </a:bodyPr>
-          <a:lstStyle/>
-          <a:p>
-            <a:pPr algn="l">
-              <a:defRPr sz="1700" b="0">
-                <a:solidFill>
-                  <a:srgbClr val="4A5568"/>
-                </a:solidFill>
-                <a:latin typeface="Microsoft JhengHei"/>
-              </a:defRPr>
-            </a:pPr>
-            <a:r>
-              <a:t>• 「智富長傳」預設保單指示：可預設身故賠償如何分配予受益人</a:t>
-            </a:r>
-          </a:p>
-        </p:txBody>
-      </p:sp>
-      <p:sp>
-        <p:nvSpPr>
-          <p:cNvPr id="9" name="TextBox 8"/>
-          <p:cNvSpPr txBox="1"/>
-          <p:nvPr/>
-        </p:nvSpPr>
-        <p:spPr>
-          <a:xfrm>
-            <a:off x="685800" y="5074920"/>
-            <a:ext cx="7772400" cy="594360"/>
-          </a:xfrm>
-          <a:prstGeom prst="rect">
-            <a:avLst/>
-          </a:prstGeom>
-          <a:noFill/>
-        </p:spPr>
-        <p:txBody>
-          <a:bodyPr wrap="square">
-            <a:spAutoFit/>
-          </a:bodyPr>
-          <a:lstStyle/>
-          <a:p>
-            <a:pPr algn="l">
-              <a:defRPr sz="1700" b="0">
-                <a:solidFill>
-                  <a:srgbClr val="4A5568"/>
-                </a:solidFill>
-                <a:latin typeface="Microsoft JhengHei"/>
-              </a:defRPr>
-            </a:pPr>
-            <a:r>
-              <a:t>• 保費延繳保障、安心2gether 精神上無行為能力保障</a:t>
+              <a:t>建議書顯示：第 15 個保單年度（非第 5 年）現金價值總額約 HK$286,059。</a:t>
+            </a:r>
+            <a:br/>
+            <a:r>
+              <a:t>已繳總保費 HK$161,022，約為 1.78 倍。</a:t>
+            </a:r>
+            <a:br/>
+            <a:br/>
+            <a:r>
+              <a:t>此階段正值畢業與踏入社會，可作進修、創業或生活儲備的參考金額。</a:t>
+            </a:r>
+            <a:br/>
+            <a:r>
+              <a:t>紅利非保證，實際金額可升可跌。</a:t>
             </a:r>
           </a:p>
         </p:txBody>
@@ -6173,7 +6927,7 @@
               </a:defRPr>
             </a:pPr>
             <a:r>
-              <a:t>孫女成長里程碑｜預期現金價值總額（說明摘要）</a:t>
+              <a:t>買樓 · 創業 · 成家 — 回報對照</a:t>
             </a:r>
           </a:p>
         </p:txBody>
@@ -6187,7 +6941,7 @@
         <p:spPr>
           <a:xfrm>
             <a:off x="548640" y="1051560"/>
-            <a:ext cx="8046720" cy="457200"/>
+            <a:ext cx="8046720" cy="502920"/>
           </a:xfrm>
           <a:prstGeom prst="rect">
             <a:avLst/>
@@ -6209,605 +6963,191 @@
               </a:defRPr>
             </a:pPr>
             <a:r>
-              <a:t>*含非保證週年紅利及終期紅利；實際或較高或較低</a:t>
-            </a:r>
-          </a:p>
-        </p:txBody>
-      </p:sp>
-      <p:graphicFrame>
-        <p:nvGraphicFramePr>
-          <p:cNvPr id="5" name="Table 4"/>
-          <p:cNvGraphicFramePr>
-            <a:graphicFrameLocks noGrp="1"/>
-          </p:cNvGraphicFramePr>
+              <a:t>保單年度與預期現金價值總額（建議書）</a:t>
+            </a:r>
+          </a:p>
+        </p:txBody>
+      </p:sp>
+      <p:sp>
+        <p:nvSpPr>
+          <p:cNvPr id="5" name="TextBox 4"/>
+          <p:cNvSpPr txBox="1"/>
           <p:nvPr/>
-        </p:nvGraphicFramePr>
-        <p:xfrm>
-          <a:off x="457200" y="1691640"/>
-          <a:ext cx="8229600" cy="4389120"/>
-        </p:xfrm>
-        <a:graphic>
-          <a:graphicData uri="http://schemas.openxmlformats.org/drawingml/2006/table">
-            <a:tbl>
-              <a:tblPr firstRow="1" bandRow="1">
-                <a:tableStyleId>{5C22544A-7EE6-4342-B048-85BDC9FD1C3A}</a:tableStyleId>
-              </a:tblPr>
-              <a:tblGrid>
-                <a:gridCol w="2057400"/>
-                <a:gridCol w="2057400"/>
-                <a:gridCol w="2057400"/>
-                <a:gridCol w="2057400"/>
-              </a:tblGrid>
-              <a:tr h="627017">
-                <a:tc>
-                  <a:txBody>
-                    <a:bodyPr/>
-                    <a:lstStyle/>
-                    <a:p>
-                      <a:pPr algn="ctr">
-                        <a:defRPr b="1" sz="1300">
-                          <a:solidFill>
-                            <a:srgbClr val="FFFFFF"/>
-                          </a:solidFill>
-                          <a:latin typeface="Microsoft JhengHei"/>
-                        </a:defRPr>
-                      </a:pPr>
-                      <a:r>
-                        <a:t>孫女年齡</a:t>
-                      </a:r>
-                    </a:p>
-                  </a:txBody>
-                  <a:tcPr>
-                    <a:solidFill>
-                      <a:srgbClr val="1A365D"/>
-                    </a:solidFill>
-                  </a:tcPr>
-                </a:tc>
-                <a:tc>
-                  <a:txBody>
-                    <a:bodyPr/>
-                    <a:lstStyle/>
-                    <a:p>
-                      <a:pPr algn="ctr">
-                        <a:defRPr b="1" sz="1300">
-                          <a:solidFill>
-                            <a:srgbClr val="FFFFFF"/>
-                          </a:solidFill>
-                          <a:latin typeface="Microsoft JhengHei"/>
-                        </a:defRPr>
-                      </a:pPr>
-                      <a:r>
-                        <a:t>保單年度</a:t>
-                      </a:r>
-                    </a:p>
-                  </a:txBody>
-                  <a:tcPr>
-                    <a:solidFill>
-                      <a:srgbClr val="1A365D"/>
-                    </a:solidFill>
-                  </a:tcPr>
-                </a:tc>
-                <a:tc>
-                  <a:txBody>
-                    <a:bodyPr/>
-                    <a:lstStyle/>
-                    <a:p>
-                      <a:pPr algn="ctr">
-                        <a:defRPr b="1" sz="1300">
-                          <a:solidFill>
-                            <a:srgbClr val="FFFFFF"/>
-                          </a:solidFill>
-                          <a:latin typeface="Microsoft JhengHei"/>
-                        </a:defRPr>
-                      </a:pPr>
-                      <a:r>
-                        <a:t>已繳總保費</a:t>
-                      </a:r>
-                    </a:p>
-                  </a:txBody>
-                  <a:tcPr>
-                    <a:solidFill>
-                      <a:srgbClr val="1A365D"/>
-                    </a:solidFill>
-                  </a:tcPr>
-                </a:tc>
-                <a:tc>
-                  <a:txBody>
-                    <a:bodyPr/>
-                    <a:lstStyle/>
-                    <a:p>
-                      <a:pPr algn="ctr">
-                        <a:defRPr b="1" sz="1300">
-                          <a:solidFill>
-                            <a:srgbClr val="FFFFFF"/>
-                          </a:solidFill>
-                          <a:latin typeface="Microsoft JhengHei"/>
-                        </a:defRPr>
-                      </a:pPr>
-                      <a:r>
-                        <a:t>預期現金價值總額*</a:t>
-                      </a:r>
-                    </a:p>
-                  </a:txBody>
-                  <a:tcPr>
-                    <a:solidFill>
-                      <a:srgbClr val="1A365D"/>
-                    </a:solidFill>
-                  </a:tcPr>
-                </a:tc>
-              </a:tr>
-              <a:tr h="627017">
-                <a:tc>
-                  <a:txBody>
-                    <a:bodyPr/>
-                    <a:lstStyle/>
-                    <a:p>
-                      <a:pPr algn="ctr">
-                        <a:defRPr sz="1200">
-                          <a:latin typeface="Microsoft JhengHei"/>
-                        </a:defRPr>
-                      </a:pPr>
-                      <a:r>
-                        <a:t>14 歲</a:t>
-                      </a:r>
-                    </a:p>
-                  </a:txBody>
-                  <a:tcPr/>
-                </a:tc>
-                <a:tc>
-                  <a:txBody>
-                    <a:bodyPr/>
-                    <a:lstStyle/>
-                    <a:p>
-                      <a:pPr algn="ctr">
-                        <a:defRPr sz="1200">
-                          <a:latin typeface="Microsoft JhengHei"/>
-                        </a:defRPr>
-                      </a:pPr>
-                      <a:r>
-                        <a:t>5</a:t>
-                      </a:r>
-                    </a:p>
-                  </a:txBody>
-                  <a:tcPr/>
-                </a:tc>
-                <a:tc>
-                  <a:txBody>
-                    <a:bodyPr/>
-                    <a:lstStyle/>
-                    <a:p>
-                      <a:pPr algn="ctr">
-                        <a:defRPr sz="1200">
-                          <a:latin typeface="Microsoft JhengHei"/>
-                        </a:defRPr>
-                      </a:pPr>
-                      <a:r>
-                        <a:t>161,022</a:t>
-                      </a:r>
-                    </a:p>
-                  </a:txBody>
-                  <a:tcPr/>
-                </a:tc>
-                <a:tc>
-                  <a:txBody>
-                    <a:bodyPr/>
-                    <a:lstStyle/>
-                    <a:p>
-                      <a:pPr algn="ctr">
-                        <a:defRPr sz="1200">
-                          <a:latin typeface="Microsoft JhengHei"/>
-                        </a:defRPr>
-                      </a:pPr>
-                      <a:r>
-                        <a:t>286,059</a:t>
-                      </a:r>
-                    </a:p>
-                  </a:txBody>
-                  <a:tcPr/>
-                </a:tc>
-              </a:tr>
-              <a:tr h="627017">
-                <a:tc>
-                  <a:txBody>
-                    <a:bodyPr/>
-                    <a:lstStyle/>
-                    <a:p>
-                      <a:pPr algn="ctr">
-                        <a:defRPr sz="1200">
-                          <a:latin typeface="Microsoft JhengHei"/>
-                        </a:defRPr>
-                      </a:pPr>
-                      <a:r>
-                        <a:t>19 歲</a:t>
-                      </a:r>
-                    </a:p>
-                  </a:txBody>
-                  <a:tcPr>
-                    <a:solidFill>
-                      <a:srgbClr val="FFFFFF"/>
-                    </a:solidFill>
-                  </a:tcPr>
-                </a:tc>
-                <a:tc>
-                  <a:txBody>
-                    <a:bodyPr/>
-                    <a:lstStyle/>
-                    <a:p>
-                      <a:pPr algn="ctr">
-                        <a:defRPr sz="1200">
-                          <a:latin typeface="Microsoft JhengHei"/>
-                        </a:defRPr>
-                      </a:pPr>
-                      <a:r>
-                        <a:t>10</a:t>
-                      </a:r>
-                    </a:p>
-                  </a:txBody>
-                  <a:tcPr>
-                    <a:solidFill>
-                      <a:srgbClr val="FFFFFF"/>
-                    </a:solidFill>
-                  </a:tcPr>
-                </a:tc>
-                <a:tc>
-                  <a:txBody>
-                    <a:bodyPr/>
-                    <a:lstStyle/>
-                    <a:p>
-                      <a:pPr algn="ctr">
-                        <a:defRPr sz="1200">
-                          <a:latin typeface="Microsoft JhengHei"/>
-                        </a:defRPr>
-                      </a:pPr>
-                      <a:r>
-                        <a:t>161,022</a:t>
-                      </a:r>
-                    </a:p>
-                  </a:txBody>
-                  <a:tcPr>
-                    <a:solidFill>
-                      <a:srgbClr val="FFFFFF"/>
-                    </a:solidFill>
-                  </a:tcPr>
-                </a:tc>
-                <a:tc>
-                  <a:txBody>
-                    <a:bodyPr/>
-                    <a:lstStyle/>
-                    <a:p>
-                      <a:pPr algn="ctr">
-                        <a:defRPr sz="1200">
-                          <a:latin typeface="Microsoft JhengHei"/>
-                        </a:defRPr>
-                      </a:pPr>
-                      <a:r>
-                        <a:t>434,249</a:t>
-                      </a:r>
-                    </a:p>
-                  </a:txBody>
-                  <a:tcPr>
-                    <a:solidFill>
-                      <a:srgbClr val="FFFFFF"/>
-                    </a:solidFill>
-                  </a:tcPr>
-                </a:tc>
-              </a:tr>
-              <a:tr h="627017">
-                <a:tc>
-                  <a:txBody>
-                    <a:bodyPr/>
-                    <a:lstStyle/>
-                    <a:p>
-                      <a:pPr algn="ctr">
-                        <a:defRPr sz="1200">
-                          <a:latin typeface="Microsoft JhengHei"/>
-                        </a:defRPr>
-                      </a:pPr>
-                      <a:r>
-                        <a:t>24 歲</a:t>
-                      </a:r>
-                    </a:p>
-                  </a:txBody>
-                  <a:tcPr/>
-                </a:tc>
-                <a:tc>
-                  <a:txBody>
-                    <a:bodyPr/>
-                    <a:lstStyle/>
-                    <a:p>
-                      <a:pPr algn="ctr">
-                        <a:defRPr sz="1200">
-                          <a:latin typeface="Microsoft JhengHei"/>
-                        </a:defRPr>
-                      </a:pPr>
-                      <a:r>
-                        <a:t>15</a:t>
-                      </a:r>
-                    </a:p>
-                  </a:txBody>
-                  <a:tcPr/>
-                </a:tc>
-                <a:tc>
-                  <a:txBody>
-                    <a:bodyPr/>
-                    <a:lstStyle/>
-                    <a:p>
-                      <a:pPr algn="ctr">
-                        <a:defRPr sz="1200">
-                          <a:latin typeface="Microsoft JhengHei"/>
-                        </a:defRPr>
-                      </a:pPr>
-                      <a:r>
-                        <a:t>161,022</a:t>
-                      </a:r>
-                    </a:p>
-                  </a:txBody>
-                  <a:tcPr/>
-                </a:tc>
-                <a:tc>
-                  <a:txBody>
-                    <a:bodyPr/>
-                    <a:lstStyle/>
-                    <a:p>
-                      <a:pPr algn="ctr">
-                        <a:defRPr sz="1200">
-                          <a:latin typeface="Microsoft JhengHei"/>
-                        </a:defRPr>
-                      </a:pPr>
-                      <a:r>
-                        <a:t>606,259</a:t>
-                      </a:r>
-                    </a:p>
-                  </a:txBody>
-                  <a:tcPr/>
-                </a:tc>
-              </a:tr>
-              <a:tr h="627017">
-                <a:tc>
-                  <a:txBody>
-                    <a:bodyPr/>
-                    <a:lstStyle/>
-                    <a:p>
-                      <a:pPr algn="ctr">
-                        <a:defRPr sz="1200">
-                          <a:latin typeface="Microsoft JhengHei"/>
-                        </a:defRPr>
-                      </a:pPr>
-                      <a:r>
-                        <a:t>29 歲</a:t>
-                      </a:r>
-                    </a:p>
-                  </a:txBody>
-                  <a:tcPr>
-                    <a:solidFill>
-                      <a:srgbClr val="FFFFFF"/>
-                    </a:solidFill>
-                  </a:tcPr>
-                </a:tc>
-                <a:tc>
-                  <a:txBody>
-                    <a:bodyPr/>
-                    <a:lstStyle/>
-                    <a:p>
-                      <a:pPr algn="ctr">
-                        <a:defRPr sz="1200">
-                          <a:latin typeface="Microsoft JhengHei"/>
-                        </a:defRPr>
-                      </a:pPr>
-                      <a:r>
-                        <a:t>20</a:t>
-                      </a:r>
-                    </a:p>
-                  </a:txBody>
-                  <a:tcPr>
-                    <a:solidFill>
-                      <a:srgbClr val="FFFFFF"/>
-                    </a:solidFill>
-                  </a:tcPr>
-                </a:tc>
-                <a:tc>
-                  <a:txBody>
-                    <a:bodyPr/>
-                    <a:lstStyle/>
-                    <a:p>
-                      <a:pPr algn="ctr">
-                        <a:defRPr sz="1200">
-                          <a:latin typeface="Microsoft JhengHei"/>
-                        </a:defRPr>
-                      </a:pPr>
-                      <a:r>
-                        <a:t>161,022</a:t>
-                      </a:r>
-                    </a:p>
-                  </a:txBody>
-                  <a:tcPr>
-                    <a:solidFill>
-                      <a:srgbClr val="FFFFFF"/>
-                    </a:solidFill>
-                  </a:tcPr>
-                </a:tc>
-                <a:tc>
-                  <a:txBody>
-                    <a:bodyPr/>
-                    <a:lstStyle/>
-                    <a:p>
-                      <a:pPr algn="ctr">
-                        <a:defRPr sz="1200">
-                          <a:latin typeface="Microsoft JhengHei"/>
-                        </a:defRPr>
-                      </a:pPr>
-                      <a:r>
-                        <a:t>825,491</a:t>
-                      </a:r>
-                    </a:p>
-                  </a:txBody>
-                  <a:tcPr>
-                    <a:solidFill>
-                      <a:srgbClr val="FFFFFF"/>
-                    </a:solidFill>
-                  </a:tcPr>
-                </a:tc>
-              </a:tr>
-              <a:tr h="627017">
-                <a:tc>
-                  <a:txBody>
-                    <a:bodyPr/>
-                    <a:lstStyle/>
-                    <a:p>
-                      <a:pPr algn="ctr">
-                        <a:defRPr sz="1200">
-                          <a:latin typeface="Microsoft JhengHei"/>
-                        </a:defRPr>
-                      </a:pPr>
-                      <a:r>
-                        <a:t>34 歲</a:t>
-                      </a:r>
-                    </a:p>
-                  </a:txBody>
-                  <a:tcPr/>
-                </a:tc>
-                <a:tc>
-                  <a:txBody>
-                    <a:bodyPr/>
-                    <a:lstStyle/>
-                    <a:p>
-                      <a:pPr algn="ctr">
-                        <a:defRPr sz="1200">
-                          <a:latin typeface="Microsoft JhengHei"/>
-                        </a:defRPr>
-                      </a:pPr>
-                      <a:r>
-                        <a:t>25</a:t>
-                      </a:r>
-                    </a:p>
-                  </a:txBody>
-                  <a:tcPr/>
-                </a:tc>
-                <a:tc>
-                  <a:txBody>
-                    <a:bodyPr/>
-                    <a:lstStyle/>
-                    <a:p>
-                      <a:pPr algn="ctr">
-                        <a:defRPr sz="1200">
-                          <a:latin typeface="Microsoft JhengHei"/>
-                        </a:defRPr>
-                      </a:pPr>
-                      <a:r>
-                        <a:t>161,022</a:t>
-                      </a:r>
-                    </a:p>
-                  </a:txBody>
-                  <a:tcPr/>
-                </a:tc>
-                <a:tc>
-                  <a:txBody>
-                    <a:bodyPr/>
-                    <a:lstStyle/>
-                    <a:p>
-                      <a:pPr algn="ctr">
-                        <a:defRPr sz="1200">
-                          <a:latin typeface="Microsoft JhengHei"/>
-                        </a:defRPr>
-                      </a:pPr>
-                      <a:r>
-                        <a:t>1,106,259</a:t>
-                      </a:r>
-                    </a:p>
-                  </a:txBody>
-                  <a:tcPr/>
-                </a:tc>
-              </a:tr>
-              <a:tr h="627018">
-                <a:tc>
-                  <a:txBody>
-                    <a:bodyPr/>
-                    <a:lstStyle/>
-                    <a:p>
-                      <a:pPr algn="ctr">
-                        <a:defRPr sz="1200">
-                          <a:latin typeface="Microsoft JhengHei"/>
-                        </a:defRPr>
-                      </a:pPr>
-                      <a:r>
-                        <a:t>65 歲</a:t>
-                      </a:r>
-                    </a:p>
-                  </a:txBody>
-                  <a:tcPr>
-                    <a:solidFill>
-                      <a:srgbClr val="FFFFFF"/>
-                    </a:solidFill>
-                  </a:tcPr>
-                </a:tc>
-                <a:tc>
-                  <a:txBody>
-                    <a:bodyPr/>
-                    <a:lstStyle/>
-                    <a:p>
-                      <a:pPr algn="ctr">
-                        <a:defRPr sz="1200">
-                          <a:latin typeface="Microsoft JhengHei"/>
-                        </a:defRPr>
-                      </a:pPr>
-                      <a:r>
-                        <a:t>56</a:t>
-                      </a:r>
-                    </a:p>
-                  </a:txBody>
-                  <a:tcPr>
-                    <a:solidFill>
-                      <a:srgbClr val="FFFFFF"/>
-                    </a:solidFill>
-                  </a:tcPr>
-                </a:tc>
-                <a:tc>
-                  <a:txBody>
-                    <a:bodyPr/>
-                    <a:lstStyle/>
-                    <a:p>
-                      <a:pPr algn="ctr">
-                        <a:defRPr sz="1200">
-                          <a:latin typeface="Microsoft JhengHei"/>
-                        </a:defRPr>
-                      </a:pPr>
-                      <a:r>
-                        <a:t>161,022</a:t>
-                      </a:r>
-                    </a:p>
-                  </a:txBody>
-                  <a:tcPr>
-                    <a:solidFill>
-                      <a:srgbClr val="FFFFFF"/>
-                    </a:solidFill>
-                  </a:tcPr>
-                </a:tc>
-                <a:tc>
-                  <a:txBody>
-                    <a:bodyPr/>
-                    <a:lstStyle/>
-                    <a:p>
-                      <a:pPr algn="ctr">
-                        <a:defRPr sz="1200">
-                          <a:latin typeface="Microsoft JhengHei"/>
-                        </a:defRPr>
-                      </a:pPr>
-                      <a:r>
-                        <a:t>3,752,770</a:t>
-                      </a:r>
-                    </a:p>
-                  </a:txBody>
-                  <a:tcPr>
-                    <a:solidFill>
-                      <a:srgbClr val="FFFFFF"/>
-                    </a:solidFill>
-                  </a:tcPr>
-                </a:tc>
-              </a:tr>
-            </a:tbl>
-          </a:graphicData>
-        </a:graphic>
-      </p:graphicFrame>
+        </p:nvSpPr>
+        <p:spPr>
+          <a:xfrm>
+            <a:off x="685800" y="1783080"/>
+            <a:ext cx="7772400" cy="640080"/>
+          </a:xfrm>
+          <a:prstGeom prst="rect">
+            <a:avLst/>
+          </a:prstGeom>
+          <a:noFill/>
+        </p:spPr>
+        <p:txBody>
+          <a:bodyPr wrap="square">
+            <a:spAutoFit/>
+          </a:bodyPr>
+          <a:lstStyle/>
+          <a:p>
+            <a:pPr algn="l">
+              <a:defRPr sz="1800" b="0">
+                <a:solidFill>
+                  <a:srgbClr val="4A5568"/>
+                </a:solidFill>
+                <a:latin typeface="Microsoft JhengHei"/>
+              </a:defRPr>
+            </a:pPr>
+            <a:r>
+              <a:t>• 買樓首期參考：第 20 年（29 歲）約 HK$434,249 · 約 2.7 倍已繳保費</a:t>
+            </a:r>
+          </a:p>
+        </p:txBody>
+      </p:sp>
+      <p:sp>
+        <p:nvSpPr>
+          <p:cNvPr id="6" name="TextBox 5"/>
+          <p:cNvSpPr txBox="1"/>
+          <p:nvPr/>
+        </p:nvSpPr>
+        <p:spPr>
+          <a:xfrm>
+            <a:off x="685800" y="2404872"/>
+            <a:ext cx="7772400" cy="640080"/>
+          </a:xfrm>
+          <a:prstGeom prst="rect">
+            <a:avLst/>
+          </a:prstGeom>
+          <a:noFill/>
+        </p:spPr>
+        <p:txBody>
+          <a:bodyPr wrap="square">
+            <a:spAutoFit/>
+          </a:bodyPr>
+          <a:lstStyle/>
+          <a:p>
+            <a:pPr algn="l">
+              <a:defRPr sz="1800" b="0">
+                <a:solidFill>
+                  <a:srgbClr val="4A5568"/>
+                </a:solidFill>
+                <a:latin typeface="Microsoft JhengHei"/>
+              </a:defRPr>
+            </a:pPr>
+            <a:r>
+              <a:t>• 結婚成家參考：第 25 年（34 歲）約 HK$606,259 · 約 3.8 倍</a:t>
+            </a:r>
+          </a:p>
+        </p:txBody>
+      </p:sp>
+      <p:sp>
+        <p:nvSpPr>
+          <p:cNvPr id="7" name="TextBox 6"/>
+          <p:cNvSpPr txBox="1"/>
+          <p:nvPr/>
+        </p:nvSpPr>
+        <p:spPr>
+          <a:xfrm>
+            <a:off x="685800" y="3026664"/>
+            <a:ext cx="7772400" cy="640080"/>
+          </a:xfrm>
+          <a:prstGeom prst="rect">
+            <a:avLst/>
+          </a:prstGeom>
+          <a:noFill/>
+        </p:spPr>
+        <p:txBody>
+          <a:bodyPr wrap="square">
+            <a:spAutoFit/>
+          </a:bodyPr>
+          <a:lstStyle/>
+          <a:p>
+            <a:pPr algn="l">
+              <a:defRPr sz="1800" b="0">
+                <a:solidFill>
+                  <a:srgbClr val="4A5568"/>
+                </a:solidFill>
+                <a:latin typeface="Microsoft JhengHei"/>
+              </a:defRPr>
+            </a:pPr>
+            <a:r>
+              <a:t>• 育兒家庭參考：第 30 年（39 歲）約 HK$825,491 · 約 5.1 倍</a:t>
+            </a:r>
+          </a:p>
+        </p:txBody>
+      </p:sp>
+      <p:sp>
+        <p:nvSpPr>
+          <p:cNvPr id="8" name="TextBox 7"/>
+          <p:cNvSpPr txBox="1"/>
+          <p:nvPr/>
+        </p:nvSpPr>
+        <p:spPr>
+          <a:xfrm>
+            <a:off x="685800" y="3648456"/>
+            <a:ext cx="7772400" cy="640080"/>
+          </a:xfrm>
+          <a:prstGeom prst="rect">
+            <a:avLst/>
+          </a:prstGeom>
+          <a:noFill/>
+        </p:spPr>
+        <p:txBody>
+          <a:bodyPr wrap="square">
+            <a:spAutoFit/>
+          </a:bodyPr>
+          <a:lstStyle/>
+          <a:p>
+            <a:pPr algn="l">
+              <a:defRPr sz="1800" b="0">
+                <a:solidFill>
+                  <a:srgbClr val="4A5568"/>
+                </a:solidFill>
+                <a:latin typeface="Microsoft JhengHei"/>
+              </a:defRPr>
+            </a:pPr>
+            <a:r>
+              <a:t>• 創業／生意周轉參考：第 35 年（44 歲）約 HK$1,106,259 · 約 6.9 倍</a:t>
+            </a:r>
+          </a:p>
+        </p:txBody>
+      </p:sp>
+      <p:sp>
+        <p:nvSpPr>
+          <p:cNvPr id="9" name="TextBox 8"/>
+          <p:cNvSpPr txBox="1"/>
+          <p:nvPr/>
+        </p:nvSpPr>
+        <p:spPr>
+          <a:xfrm>
+            <a:off x="685800" y="4270248"/>
+            <a:ext cx="7772400" cy="640080"/>
+          </a:xfrm>
+          <a:prstGeom prst="rect">
+            <a:avLst/>
+          </a:prstGeom>
+          <a:noFill/>
+        </p:spPr>
+        <p:txBody>
+          <a:bodyPr wrap="square">
+            <a:spAutoFit/>
+          </a:bodyPr>
+          <a:lstStyle/>
+          <a:p>
+            <a:pPr algn="l">
+              <a:defRPr sz="1800" b="0">
+                <a:solidFill>
+                  <a:srgbClr val="4A5568"/>
+                </a:solidFill>
+                <a:latin typeface="Microsoft JhengHei"/>
+              </a:defRPr>
+            </a:pPr>
+            <a:r>
+              <a:t>• 提取方式：部分退保、紅利提取或保單貸款等，須按條款及當時保單價值</a:t>
+            </a:r>
+          </a:p>
+        </p:txBody>
+      </p:sp>
     </p:spTree>
   </p:cSld>
   <p:clrMapOvr>
@@ -6908,7 +7248,7 @@
               </a:defRPr>
             </a:pPr>
             <a:r>
-              <a:t>長遠參考：受保人 65 歲保單週年日</a:t>
+              <a:t>計劃功能（配合孫女長線儲蓄）</a:t>
             </a:r>
           </a:p>
         </p:txBody>
@@ -6921,8 +7261,8 @@
         </p:nvSpPr>
         <p:spPr>
           <a:xfrm>
-            <a:off x="548640" y="1051560"/>
-            <a:ext cx="8046720" cy="457200"/>
+            <a:off x="685800" y="1783080"/>
+            <a:ext cx="7772400" cy="640080"/>
           </a:xfrm>
           <a:prstGeom prst="rect">
             <a:avLst/>
@@ -6936,15 +7276,15 @@
           <a:lstStyle/>
           <a:p>
             <a:pPr algn="l">
-              <a:defRPr sz="1600" b="0">
-                <a:solidFill>
-                  <a:srgbClr val="718590"/>
+              <a:defRPr sz="1700" b="0">
+                <a:solidFill>
+                  <a:srgbClr val="4A5568"/>
                 </a:solidFill>
                 <a:latin typeface="Microsoft JhengHei"/>
               </a:defRPr>
             </a:pPr>
             <a:r>
-              <a:t>非保證；僅作說明摘要演示</a:t>
+              <a:t>• 週年紅利（非保證）：可積存生息，日後按人生需要提取</a:t>
             </a:r>
           </a:p>
         </p:txBody>
@@ -6957,8 +7297,8 @@
         </p:nvSpPr>
         <p:spPr>
           <a:xfrm>
-            <a:off x="640080" y="1737360"/>
-            <a:ext cx="7863840" cy="1097280"/>
+            <a:off x="685800" y="2404872"/>
+            <a:ext cx="7772400" cy="640080"/>
           </a:xfrm>
           <a:prstGeom prst="rect">
             <a:avLst/>
@@ -6972,19 +7312,15 @@
           <a:lstStyle/>
           <a:p>
             <a:pPr algn="l">
-              <a:defRPr sz="2200" b="1">
-                <a:solidFill>
-                  <a:srgbClr val="059669"/>
+              <a:defRPr sz="1700" b="0">
+                <a:solidFill>
+                  <a:srgbClr val="4A5568"/>
                 </a:solidFill>
                 <a:latin typeface="Microsoft JhengHei"/>
               </a:defRPr>
             </a:pPr>
             <a:r>
-              <a:t>預期現金價值總額約 HK$3,752,770（已繳總保費 HK$161,022）</a:t>
-            </a:r>
-            <a:br/>
-            <a:r>
-              <a:t>約為已繳總保費的 23.3 倍*</a:t>
+              <a:t>• 終期紅利（非保證）：退保或身故時派發，長線增值主力</a:t>
             </a:r>
           </a:p>
         </p:txBody>
@@ -6997,8 +7333,8 @@
         </p:nvSpPr>
         <p:spPr>
           <a:xfrm>
-            <a:off x="640080" y="3017520"/>
-            <a:ext cx="7863840" cy="2286000"/>
+            <a:off x="685800" y="3026664"/>
+            <a:ext cx="7772400" cy="640080"/>
           </a:xfrm>
           <a:prstGeom prst="rect">
             <a:avLst/>
@@ -7012,15 +7348,87 @@
           <a:lstStyle/>
           <a:p>
             <a:pPr algn="l">
-              <a:defRPr sz="1600" b="0">
-                <a:solidFill>
-                  <a:srgbClr val="718590"/>
+              <a:defRPr sz="1700" b="0">
+                <a:solidFill>
+                  <a:srgbClr val="4A5568"/>
                 </a:solidFill>
                 <a:latin typeface="Microsoft JhengHei"/>
               </a:defRPr>
             </a:pPr>
             <a:r>
-              <a:t>此數字包含保證現金價值、累積週年紅利（非保證）及終期紅利（非保證）。紅利並非保證，可升可跌，過往表現不代表將來。</a:t>
+              <a:t>• 更改受保人：孫女長大後可傳予下一代，保單繼續生效</a:t>
+            </a:r>
+          </a:p>
+        </p:txBody>
+      </p:sp>
+      <p:sp>
+        <p:nvSpPr>
+          <p:cNvPr id="7" name="TextBox 6"/>
+          <p:cNvSpPr txBox="1"/>
+          <p:nvPr/>
+        </p:nvSpPr>
+        <p:spPr>
+          <a:xfrm>
+            <a:off x="685800" y="3648456"/>
+            <a:ext cx="7772400" cy="640080"/>
+          </a:xfrm>
+          <a:prstGeom prst="rect">
+            <a:avLst/>
+          </a:prstGeom>
+          <a:noFill/>
+        </p:spPr>
+        <p:txBody>
+          <a:bodyPr wrap="square">
+            <a:spAutoFit/>
+          </a:bodyPr>
+          <a:lstStyle/>
+          <a:p>
+            <a:pPr algn="l">
+              <a:defRPr sz="1700" b="0">
+                <a:solidFill>
+                  <a:srgbClr val="4A5568"/>
+                </a:solidFill>
+                <a:latin typeface="Microsoft JhengHei"/>
+              </a:defRPr>
+            </a:pPr>
+            <a:r>
+              <a:t>• 保單分拆、貨幣轉換（如適用）：配合移民、置業或多元配置</a:t>
+            </a:r>
+          </a:p>
+        </p:txBody>
+      </p:sp>
+      <p:sp>
+        <p:nvSpPr>
+          <p:cNvPr id="8" name="TextBox 7"/>
+          <p:cNvSpPr txBox="1"/>
+          <p:nvPr/>
+        </p:nvSpPr>
+        <p:spPr>
+          <a:xfrm>
+            <a:off x="685800" y="4270248"/>
+            <a:ext cx="7772400" cy="640080"/>
+          </a:xfrm>
+          <a:prstGeom prst="rect">
+            <a:avLst/>
+          </a:prstGeom>
+          <a:noFill/>
+        </p:spPr>
+        <p:txBody>
+          <a:bodyPr wrap="square">
+            <a:spAutoFit/>
+          </a:bodyPr>
+          <a:lstStyle/>
+          <a:p>
+            <a:pPr algn="l">
+              <a:defRPr sz="1700" b="0">
+                <a:solidFill>
+                  <a:srgbClr val="4A5568"/>
+                </a:solidFill>
+                <a:latin typeface="Microsoft JhengHei"/>
+              </a:defRPr>
+            </a:pPr>
+            <a:r>
+              <a:t>• 「智富長傳」：可預設身故賠償分期給受益人，避免一次過揮霍</a:t>
             </a:r>
           </a:p>
         </p:txBody>

</xml_diff>